<commit_message>
fix: correct presentation source notes
</commit_message>
<xml_diff>
--- a/paper/presentation/KSC_PILOT_presentation.pptx
+++ b/paper/presentation/KSC_PILOT_presentation.pptx
@@ -2,22 +2,22 @@
 <file path=ppt/presentation.xml><?xml version="1.0" encoding="utf-8"?>
 <p:presentation xmlns:p="http://schemas.openxmlformats.org/presentationml/2006/main">
   <p:sldMasterIdLst>
-    <p:sldMasterId xmlns:r="http://schemas.openxmlformats.org/officeDocument/2006/relationships" id="2147483648" r:id="Rb4b78838fe434db7"/>
+    <p:sldMasterId xmlns:r="http://schemas.openxmlformats.org/officeDocument/2006/relationships" id="2147483648" r:id="R1a0879dd590f46fd"/>
   </p:sldMasterIdLst>
   <p:notesMasterIdLst>
-    <p:notesMasterId xmlns:r="http://schemas.openxmlformats.org/officeDocument/2006/relationships" r:id="R416518b3eb0645b2"/>
+    <p:notesMasterId xmlns:r="http://schemas.openxmlformats.org/officeDocument/2006/relationships" r:id="R107ba4b628134595"/>
   </p:notesMasterIdLst>
   <p:sldIdLst>
-    <p:sldId xmlns:r="http://schemas.openxmlformats.org/officeDocument/2006/relationships" id="256" r:id="R82624cd758104509"/>
-    <p:sldId xmlns:r="http://schemas.openxmlformats.org/officeDocument/2006/relationships" id="257" r:id="R10695f8e3e354562"/>
-    <p:sldId xmlns:r="http://schemas.openxmlformats.org/officeDocument/2006/relationships" id="258" r:id="R2fc4b53570354983"/>
-    <p:sldId xmlns:r="http://schemas.openxmlformats.org/officeDocument/2006/relationships" id="259" r:id="R0fdd857d3fd64402"/>
-    <p:sldId xmlns:r="http://schemas.openxmlformats.org/officeDocument/2006/relationships" id="260" r:id="Rc6e8f7cd923f4835"/>
-    <p:sldId xmlns:r="http://schemas.openxmlformats.org/officeDocument/2006/relationships" id="261" r:id="R82ba3523bcb24536"/>
-    <p:sldId xmlns:r="http://schemas.openxmlformats.org/officeDocument/2006/relationships" id="262" r:id="R48adb7bb0cd841df"/>
-    <p:sldId xmlns:r="http://schemas.openxmlformats.org/officeDocument/2006/relationships" id="263" r:id="R3beab70d6b014d8a"/>
-    <p:sldId xmlns:r="http://schemas.openxmlformats.org/officeDocument/2006/relationships" id="264" r:id="R0e513cafb5dc4fc4"/>
-    <p:sldId xmlns:r="http://schemas.openxmlformats.org/officeDocument/2006/relationships" id="265" r:id="R0a68a081cbd144c0"/>
+    <p:sldId xmlns:r="http://schemas.openxmlformats.org/officeDocument/2006/relationships" id="256" r:id="R2b1297a6f28d420f"/>
+    <p:sldId xmlns:r="http://schemas.openxmlformats.org/officeDocument/2006/relationships" id="257" r:id="R0b6beab32b1b4140"/>
+    <p:sldId xmlns:r="http://schemas.openxmlformats.org/officeDocument/2006/relationships" id="258" r:id="Rd19b890e53f3457f"/>
+    <p:sldId xmlns:r="http://schemas.openxmlformats.org/officeDocument/2006/relationships" id="259" r:id="R9b3cc37d52f4434a"/>
+    <p:sldId xmlns:r="http://schemas.openxmlformats.org/officeDocument/2006/relationships" id="260" r:id="R821a8255da7d4579"/>
+    <p:sldId xmlns:r="http://schemas.openxmlformats.org/officeDocument/2006/relationships" id="261" r:id="R36c1ba71f66145b8"/>
+    <p:sldId xmlns:r="http://schemas.openxmlformats.org/officeDocument/2006/relationships" id="262" r:id="Rf4296e3f347544c4"/>
+    <p:sldId xmlns:r="http://schemas.openxmlformats.org/officeDocument/2006/relationships" id="263" r:id="R45ddfce14bbd4095"/>
+    <p:sldId xmlns:r="http://schemas.openxmlformats.org/officeDocument/2006/relationships" id="264" r:id="Rb71b29c8f24b4e74"/>
+    <p:sldId xmlns:r="http://schemas.openxmlformats.org/officeDocument/2006/relationships" id="265" r:id="R7b4d993fbfa04165"/>
   </p:sldIdLst>
   <p:sldSz cx="12192000" cy="6858000"/>
   <p:notesSz cx="6858000" cy="9144000"/>
@@ -1206,7 +1206,7 @@
           </a:p>
           <a:p xmlns:a="http://schemas.openxmlformats.org/drawingml/2006/main">
             <a:r>
-              <a:t>- https://openreview.net/forum?id=ZGU6p8kR9O</a:t>
+              <a:t>- https://openreview.net/forum?id=8sSqNntaMr</a:t>
             </a:r>
           </a:p>
           <a:p xmlns:a="http://schemas.openxmlformats.org/drawingml/2006/main">
@@ -1369,7 +1369,7 @@
   </p:cSld>
   <p:clrMap bg1="lt1" tx1="dk1" bg2="lt2" tx2="dk2" accent1="accent1" accent2="accent2" accent3="accent3" accent4="accent4" accent5="accent5" accent6="accent6" hlink="hlink" folHlink="folHlink"/>
   <p:sldLayoutIdLst>
-    <p:sldLayoutId xmlns:r="http://schemas.openxmlformats.org/officeDocument/2006/relationships" id="2147483649" r:id="R6e237514edbf4b04"/>
+    <p:sldLayoutId xmlns:r="http://schemas.openxmlformats.org/officeDocument/2006/relationships" id="2147483649" r:id="R2bf73a13f4fa458b"/>
   </p:sldLayoutIdLst>
   <p:txStyles>
     <p:titleStyle>
@@ -1979,6 +1979,7 @@
           <a:lstStyle xmlns:a="http://schemas.openxmlformats.org/drawingml/2006/main"/>
           <a:p xmlns:a="http://schemas.openxmlformats.org/drawingml/2006/main">
             <a:pPr algn="l">
+              <a:buNone/>
               <a:defRPr sz="3900" b="1">
                 <a:solidFill>
                   <a:srgbClr val="0F172A"/>
@@ -1996,6 +1997,7 @@
           </a:p>
           <a:p xmlns:a="http://schemas.openxmlformats.org/drawingml/2006/main">
             <a:pPr algn="l">
+              <a:buNone/>
               <a:defRPr sz="3900" b="1">
                 <a:solidFill>
                   <a:srgbClr val="0F172A"/>
@@ -2046,6 +2048,7 @@
           <a:lstStyle xmlns:a="http://schemas.openxmlformats.org/drawingml/2006/main"/>
           <a:p xmlns:a="http://schemas.openxmlformats.org/drawingml/2006/main">
             <a:pPr algn="l">
+              <a:buNone/>
               <a:defRPr sz="1800" b="0">
                 <a:solidFill>
                   <a:srgbClr val="5B677A"/>
@@ -2096,6 +2099,7 @@
           <a:lstStyle xmlns:a="http://schemas.openxmlformats.org/drawingml/2006/main"/>
           <a:p xmlns:a="http://schemas.openxmlformats.org/drawingml/2006/main">
             <a:pPr algn="l">
+              <a:buNone/>
               <a:defRPr sz="1275" b="1">
                 <a:solidFill>
                   <a:srgbClr val="7C3AED"/>
@@ -2146,6 +2150,7 @@
           <a:lstStyle xmlns:a="http://schemas.openxmlformats.org/drawingml/2006/main"/>
           <a:p xmlns:a="http://schemas.openxmlformats.org/drawingml/2006/main">
             <a:pPr algn="l">
+              <a:buNone/>
               <a:defRPr sz="3900" b="1">
                 <a:solidFill>
                   <a:srgbClr val="2563EB"/>
@@ -2196,6 +2201,7 @@
           <a:lstStyle xmlns:a="http://schemas.openxmlformats.org/drawingml/2006/main"/>
           <a:p xmlns:a="http://schemas.openxmlformats.org/drawingml/2006/main">
             <a:pPr algn="l">
+              <a:buNone/>
               <a:defRPr sz="1425" b="0">
                 <a:solidFill>
                   <a:srgbClr val="5B677A"/>
@@ -2246,6 +2252,7 @@
           <a:lstStyle xmlns:a="http://schemas.openxmlformats.org/drawingml/2006/main"/>
           <a:p xmlns:a="http://schemas.openxmlformats.org/drawingml/2006/main">
             <a:pPr algn="l">
+              <a:buNone/>
               <a:defRPr sz="3900" b="1">
                 <a:solidFill>
                   <a:srgbClr val="7C3AED"/>
@@ -2296,6 +2303,7 @@
           <a:lstStyle xmlns:a="http://schemas.openxmlformats.org/drawingml/2006/main"/>
           <a:p xmlns:a="http://schemas.openxmlformats.org/drawingml/2006/main">
             <a:pPr algn="l">
+              <a:buNone/>
               <a:defRPr sz="1425" b="0">
                 <a:solidFill>
                   <a:srgbClr val="5B677A"/>
@@ -2346,6 +2354,7 @@
           <a:lstStyle xmlns:a="http://schemas.openxmlformats.org/drawingml/2006/main"/>
           <a:p xmlns:a="http://schemas.openxmlformats.org/drawingml/2006/main">
             <a:pPr algn="r">
+              <a:buNone/>
               <a:defRPr sz="1500" b="1">
                 <a:solidFill>
                   <a:srgbClr val="0F172A"/>
@@ -2396,6 +2405,7 @@
           <a:lstStyle xmlns:a="http://schemas.openxmlformats.org/drawingml/2006/main"/>
           <a:p xmlns:a="http://schemas.openxmlformats.org/drawingml/2006/main">
             <a:pPr algn="l">
+              <a:buNone/>
               <a:defRPr sz="825" b="0">
                 <a:solidFill>
                   <a:srgbClr val="8490A3"/>
@@ -2446,6 +2456,7 @@
           <a:lstStyle xmlns:a="http://schemas.openxmlformats.org/drawingml/2006/main"/>
           <a:p xmlns:a="http://schemas.openxmlformats.org/drawingml/2006/main">
             <a:pPr algn="r">
+              <a:buNone/>
               <a:defRPr sz="825" b="0">
                 <a:solidFill>
                   <a:srgbClr val="8490A3"/>
@@ -2525,6 +2536,7 @@
           <a:lstStyle xmlns:a="http://schemas.openxmlformats.org/drawingml/2006/main"/>
           <a:p xmlns:a="http://schemas.openxmlformats.org/drawingml/2006/main">
             <a:pPr algn="l">
+              <a:buNone/>
               <a:defRPr sz="1125" b="1">
                 <a:solidFill>
                   <a:srgbClr val="7C3AED"/>
@@ -2575,6 +2587,7 @@
           <a:lstStyle xmlns:a="http://schemas.openxmlformats.org/drawingml/2006/main"/>
           <a:p xmlns:a="http://schemas.openxmlformats.org/drawingml/2006/main">
             <a:pPr algn="l">
+              <a:buNone/>
               <a:defRPr sz="3900" b="1">
                 <a:solidFill>
                   <a:srgbClr val="0F172A"/>
@@ -2592,6 +2605,7 @@
           </a:p>
           <a:p xmlns:a="http://schemas.openxmlformats.org/drawingml/2006/main">
             <a:pPr algn="l">
+              <a:buNone/>
               <a:defRPr sz="3900" b="1">
                 <a:solidFill>
                   <a:srgbClr val="0F172A"/>
@@ -2706,6 +2720,7 @@
           <a:lstStyle xmlns:a="http://schemas.openxmlformats.org/drawingml/2006/main"/>
           <a:p xmlns:a="http://schemas.openxmlformats.org/drawingml/2006/main">
             <a:pPr algn="l">
+              <a:buNone/>
               <a:defRPr sz="1725" b="0">
                 <a:solidFill>
                   <a:srgbClr val="0F172A"/>
@@ -2789,6 +2804,7 @@
           <a:lstStyle xmlns:a="http://schemas.openxmlformats.org/drawingml/2006/main"/>
           <a:p xmlns:a="http://schemas.openxmlformats.org/drawingml/2006/main">
             <a:pPr algn="l">
+              <a:buNone/>
               <a:defRPr sz="1725" b="0">
                 <a:solidFill>
                   <a:srgbClr val="0F172A"/>
@@ -2872,6 +2888,7 @@
           <a:lstStyle xmlns:a="http://schemas.openxmlformats.org/drawingml/2006/main"/>
           <a:p xmlns:a="http://schemas.openxmlformats.org/drawingml/2006/main">
             <a:pPr algn="l">
+              <a:buNone/>
               <a:defRPr sz="1725" b="0">
                 <a:solidFill>
                   <a:srgbClr val="0F172A"/>
@@ -2922,6 +2939,7 @@
           <a:lstStyle xmlns:a="http://schemas.openxmlformats.org/drawingml/2006/main"/>
           <a:p xmlns:a="http://schemas.openxmlformats.org/drawingml/2006/main">
             <a:pPr algn="l">
+              <a:buNone/>
               <a:defRPr sz="1650" b="1">
                 <a:solidFill>
                   <a:srgbClr val="5B677A"/>
@@ -2972,6 +2990,7 @@
           <a:lstStyle xmlns:a="http://schemas.openxmlformats.org/drawingml/2006/main"/>
           <a:p xmlns:a="http://schemas.openxmlformats.org/drawingml/2006/main">
             <a:pPr algn="l">
+              <a:buNone/>
               <a:defRPr sz="1725" b="1">
                 <a:solidFill>
                   <a:srgbClr val="7C3AED"/>
@@ -2989,6 +3008,7 @@
           </a:p>
           <a:p xmlns:a="http://schemas.openxmlformats.org/drawingml/2006/main">
             <a:pPr algn="l">
+              <a:buNone/>
               <a:defRPr sz="1725" b="1">
                 <a:solidFill>
                   <a:srgbClr val="7C3AED"/>
@@ -3006,6 +3026,7 @@
           </a:p>
           <a:p xmlns:a="http://schemas.openxmlformats.org/drawingml/2006/main">
             <a:pPr algn="l">
+              <a:buNone/>
               <a:defRPr sz="1725" b="1">
                 <a:solidFill>
                   <a:srgbClr val="7C3AED"/>
@@ -3056,6 +3077,7 @@
           <a:lstStyle xmlns:a="http://schemas.openxmlformats.org/drawingml/2006/main"/>
           <a:p xmlns:a="http://schemas.openxmlformats.org/drawingml/2006/main">
             <a:pPr algn="l">
+              <a:buNone/>
               <a:defRPr sz="1275" b="0">
                 <a:solidFill>
                   <a:srgbClr val="2563EB"/>
@@ -3106,6 +3128,7 @@
           <a:lstStyle xmlns:a="http://schemas.openxmlformats.org/drawingml/2006/main"/>
           <a:p xmlns:a="http://schemas.openxmlformats.org/drawingml/2006/main">
             <a:pPr algn="l">
+              <a:buNone/>
               <a:defRPr sz="825" b="0">
                 <a:solidFill>
                   <a:srgbClr val="8490A3"/>
@@ -3156,6 +3179,7 @@
           <a:lstStyle xmlns:a="http://schemas.openxmlformats.org/drawingml/2006/main"/>
           <a:p xmlns:a="http://schemas.openxmlformats.org/drawingml/2006/main">
             <a:pPr algn="r">
+              <a:buNone/>
               <a:defRPr sz="825" b="0">
                 <a:solidFill>
                   <a:srgbClr val="8490A3"/>
@@ -3235,6 +3259,7 @@
           <a:lstStyle xmlns:a="http://schemas.openxmlformats.org/drawingml/2006/main"/>
           <a:p xmlns:a="http://schemas.openxmlformats.org/drawingml/2006/main">
             <a:pPr algn="l">
+              <a:buNone/>
               <a:defRPr sz="975" b="1">
                 <a:solidFill>
                   <a:srgbClr val="7C3AED"/>
@@ -3285,6 +3310,7 @@
           <a:lstStyle xmlns:a="http://schemas.openxmlformats.org/drawingml/2006/main"/>
           <a:p xmlns:a="http://schemas.openxmlformats.org/drawingml/2006/main">
             <a:pPr algn="l">
+              <a:buNone/>
               <a:defRPr sz="2700" b="1">
                 <a:solidFill>
                   <a:srgbClr val="0F172A"/>
@@ -3366,6 +3392,7 @@
           <a:lstStyle xmlns:a="http://schemas.openxmlformats.org/drawingml/2006/main"/>
           <a:p xmlns:a="http://schemas.openxmlformats.org/drawingml/2006/main">
             <a:pPr algn="l">
+              <a:buNone/>
               <a:defRPr sz="1800" b="1">
                 <a:solidFill>
                   <a:srgbClr val="5B677A"/>
@@ -3416,6 +3443,7 @@
           <a:lstStyle xmlns:a="http://schemas.openxmlformats.org/drawingml/2006/main"/>
           <a:p xmlns:a="http://schemas.openxmlformats.org/drawingml/2006/main">
             <a:pPr algn="l">
+              <a:buNone/>
               <a:defRPr sz="1875" b="1">
                 <a:solidFill>
                   <a:srgbClr val="0F172A"/>
@@ -3466,6 +3494,7 @@
           <a:lstStyle xmlns:a="http://schemas.openxmlformats.org/drawingml/2006/main"/>
           <a:p xmlns:a="http://schemas.openxmlformats.org/drawingml/2006/main">
             <a:pPr algn="ctr">
+              <a:buNone/>
               <a:defRPr sz="2100" b="1">
                 <a:solidFill>
                   <a:srgbClr val="5B677A"/>
@@ -3516,6 +3545,7 @@
           <a:lstStyle xmlns:a="http://schemas.openxmlformats.org/drawingml/2006/main"/>
           <a:p xmlns:a="http://schemas.openxmlformats.org/drawingml/2006/main">
             <a:pPr algn="l">
+              <a:buNone/>
               <a:defRPr sz="1875" b="1">
                 <a:solidFill>
                   <a:srgbClr val="0F172A"/>
@@ -3566,6 +3596,7 @@
           <a:lstStyle xmlns:a="http://schemas.openxmlformats.org/drawingml/2006/main"/>
           <a:p xmlns:a="http://schemas.openxmlformats.org/drawingml/2006/main">
             <a:pPr algn="l">
+              <a:buNone/>
               <a:defRPr sz="1725" b="0">
                 <a:solidFill>
                   <a:srgbClr val="B91C1C"/>
@@ -3583,6 +3614,7 @@
           </a:p>
           <a:p xmlns:a="http://schemas.openxmlformats.org/drawingml/2006/main">
             <a:pPr algn="l">
+              <a:buNone/>
               <a:defRPr sz="1725" b="0">
                 <a:solidFill>
                   <a:srgbClr val="B91C1C"/>
@@ -3664,6 +3696,7 @@
           <a:lstStyle xmlns:a="http://schemas.openxmlformats.org/drawingml/2006/main"/>
           <a:p xmlns:a="http://schemas.openxmlformats.org/drawingml/2006/main">
             <a:pPr algn="l">
+              <a:buNone/>
               <a:defRPr sz="1800" b="1">
                 <a:solidFill>
                   <a:srgbClr val="7C3AED"/>
@@ -3747,6 +3780,7 @@
           <a:lstStyle xmlns:a="http://schemas.openxmlformats.org/drawingml/2006/main"/>
           <a:p xmlns:a="http://schemas.openxmlformats.org/drawingml/2006/main">
             <a:pPr algn="l">
+              <a:buNone/>
               <a:defRPr sz="1650" b="0">
                 <a:solidFill>
                   <a:srgbClr val="0F172A"/>
@@ -3830,6 +3864,7 @@
           <a:lstStyle xmlns:a="http://schemas.openxmlformats.org/drawingml/2006/main"/>
           <a:p xmlns:a="http://schemas.openxmlformats.org/drawingml/2006/main">
             <a:pPr algn="l">
+              <a:buNone/>
               <a:defRPr sz="1650" b="0">
                 <a:solidFill>
                   <a:srgbClr val="0F172A"/>
@@ -3913,6 +3948,7 @@
           <a:lstStyle xmlns:a="http://schemas.openxmlformats.org/drawingml/2006/main"/>
           <a:p xmlns:a="http://schemas.openxmlformats.org/drawingml/2006/main">
             <a:pPr algn="l">
+              <a:buNone/>
               <a:defRPr sz="1650" b="0">
                 <a:solidFill>
                   <a:srgbClr val="0F172A"/>
@@ -3996,6 +4032,7 @@
           <a:lstStyle xmlns:a="http://schemas.openxmlformats.org/drawingml/2006/main"/>
           <a:p xmlns:a="http://schemas.openxmlformats.org/drawingml/2006/main">
             <a:pPr algn="l">
+              <a:buNone/>
               <a:defRPr sz="1650" b="0">
                 <a:solidFill>
                   <a:srgbClr val="0F172A"/>
@@ -4046,6 +4083,7 @@
           <a:lstStyle xmlns:a="http://schemas.openxmlformats.org/drawingml/2006/main"/>
           <a:p xmlns:a="http://schemas.openxmlformats.org/drawingml/2006/main">
             <a:pPr algn="l">
+              <a:buNone/>
               <a:defRPr sz="2400" b="1">
                 <a:solidFill>
                   <a:srgbClr val="2563EB"/>
@@ -4096,6 +4134,7 @@
           <a:lstStyle xmlns:a="http://schemas.openxmlformats.org/drawingml/2006/main"/>
           <a:p xmlns:a="http://schemas.openxmlformats.org/drawingml/2006/main">
             <a:pPr algn="l">
+              <a:buNone/>
               <a:defRPr sz="825" b="0">
                 <a:solidFill>
                   <a:srgbClr val="8490A3"/>
@@ -4146,6 +4185,7 @@
           <a:lstStyle xmlns:a="http://schemas.openxmlformats.org/drawingml/2006/main"/>
           <a:p xmlns:a="http://schemas.openxmlformats.org/drawingml/2006/main">
             <a:pPr algn="r">
+              <a:buNone/>
               <a:defRPr sz="825" b="0">
                 <a:solidFill>
                   <a:srgbClr val="8490A3"/>
@@ -4225,6 +4265,7 @@
           <a:lstStyle xmlns:a="http://schemas.openxmlformats.org/drawingml/2006/main"/>
           <a:p xmlns:a="http://schemas.openxmlformats.org/drawingml/2006/main">
             <a:pPr algn="l">
+              <a:buNone/>
               <a:defRPr sz="975" b="1">
                 <a:solidFill>
                   <a:srgbClr val="7C3AED"/>
@@ -4275,6 +4316,7 @@
           <a:lstStyle xmlns:a="http://schemas.openxmlformats.org/drawingml/2006/main"/>
           <a:p xmlns:a="http://schemas.openxmlformats.org/drawingml/2006/main">
             <a:pPr algn="l">
+              <a:buNone/>
               <a:defRPr sz="2700" b="1">
                 <a:solidFill>
                   <a:srgbClr val="0F172A"/>
@@ -4325,14 +4367,14 @@
       </p:sp>
       <p:pic>
         <p:nvPicPr>
-          <p:cNvPr id="14" name=""/>
+          <p:cNvPr id="16" name=""/>
           <p:cNvPicPr>
             <a:picLocks xmlns:a="http://schemas.openxmlformats.org/drawingml/2006/main" noChangeAspect="1"/>
           </p:cNvPicPr>
           <p:nvPr/>
         </p:nvPicPr>
         <p:blipFill>
-          <a:blip xmlns:r="http://schemas.openxmlformats.org/officeDocument/2006/relationships" xmlns:a="http://schemas.openxmlformats.org/drawingml/2006/main" r:embed="Rca14c89e7bf443d4"/>
+          <a:blip xmlns:r="http://schemas.openxmlformats.org/officeDocument/2006/relationships" xmlns:a="http://schemas.openxmlformats.org/drawingml/2006/main" r:embed="R5ddd54eca7fc4c2b"/>
           <a:stretch xmlns:a="http://schemas.openxmlformats.org/drawingml/2006/main"/>
         </p:blipFill>
         <p:spPr>
@@ -4378,6 +4420,7 @@
           <a:lstStyle xmlns:a="http://schemas.openxmlformats.org/drawingml/2006/main"/>
           <a:p xmlns:a="http://schemas.openxmlformats.org/drawingml/2006/main">
             <a:pPr algn="l">
+              <a:buNone/>
               <a:defRPr sz="1500" b="1">
                 <a:solidFill>
                   <a:srgbClr val="15803D"/>
@@ -4428,6 +4471,7 @@
           <a:lstStyle xmlns:a="http://schemas.openxmlformats.org/drawingml/2006/main"/>
           <a:p xmlns:a="http://schemas.openxmlformats.org/drawingml/2006/main">
             <a:pPr algn="l">
+              <a:buNone/>
               <a:defRPr sz="1500" b="1">
                 <a:solidFill>
                   <a:srgbClr val="7C3AED"/>
@@ -4478,6 +4522,7 @@
           <a:lstStyle xmlns:a="http://schemas.openxmlformats.org/drawingml/2006/main"/>
           <a:p xmlns:a="http://schemas.openxmlformats.org/drawingml/2006/main">
             <a:pPr algn="l">
+              <a:buNone/>
               <a:defRPr sz="1500" b="1">
                 <a:solidFill>
                   <a:srgbClr val="B45309"/>
@@ -4528,6 +4573,7 @@
           <a:lstStyle xmlns:a="http://schemas.openxmlformats.org/drawingml/2006/main"/>
           <a:p xmlns:a="http://schemas.openxmlformats.org/drawingml/2006/main">
             <a:pPr algn="ctr">
+              <a:buNone/>
               <a:defRPr sz="1275" b="0">
                 <a:solidFill>
                   <a:srgbClr val="5B677A"/>
@@ -4578,6 +4624,7 @@
           <a:lstStyle xmlns:a="http://schemas.openxmlformats.org/drawingml/2006/main"/>
           <a:p xmlns:a="http://schemas.openxmlformats.org/drawingml/2006/main">
             <a:pPr algn="l">
+              <a:buNone/>
               <a:defRPr sz="825" b="0">
                 <a:solidFill>
                   <a:srgbClr val="8490A3"/>
@@ -4628,6 +4675,7 @@
           <a:lstStyle xmlns:a="http://schemas.openxmlformats.org/drawingml/2006/main"/>
           <a:p xmlns:a="http://schemas.openxmlformats.org/drawingml/2006/main">
             <a:pPr algn="r">
+              <a:buNone/>
               <a:defRPr sz="825" b="0">
                 <a:solidFill>
                   <a:srgbClr val="8490A3"/>
@@ -4707,6 +4755,7 @@
           <a:lstStyle xmlns:a="http://schemas.openxmlformats.org/drawingml/2006/main"/>
           <a:p xmlns:a="http://schemas.openxmlformats.org/drawingml/2006/main">
             <a:pPr algn="l">
+              <a:buNone/>
               <a:defRPr sz="975" b="1">
                 <a:solidFill>
                   <a:srgbClr val="7C3AED"/>
@@ -4757,6 +4806,7 @@
           <a:lstStyle xmlns:a="http://schemas.openxmlformats.org/drawingml/2006/main"/>
           <a:p xmlns:a="http://schemas.openxmlformats.org/drawingml/2006/main">
             <a:pPr algn="l">
+              <a:buNone/>
               <a:defRPr sz="2700" b="1">
                 <a:solidFill>
                   <a:srgbClr val="0F172A"/>
@@ -4807,14 +4857,14 @@
       </p:sp>
       <p:pic>
         <p:nvPicPr>
-          <p:cNvPr id="12" name=""/>
+          <p:cNvPr id="14" name=""/>
           <p:cNvPicPr>
             <a:picLocks xmlns:a="http://schemas.openxmlformats.org/drawingml/2006/main" noChangeAspect="1"/>
           </p:cNvPicPr>
           <p:nvPr/>
         </p:nvPicPr>
         <p:blipFill>
-          <a:blip xmlns:r="http://schemas.openxmlformats.org/officeDocument/2006/relationships" xmlns:a="http://schemas.openxmlformats.org/drawingml/2006/main" r:embed="Rdda7f821d30b4623"/>
+          <a:blip xmlns:r="http://schemas.openxmlformats.org/officeDocument/2006/relationships" xmlns:a="http://schemas.openxmlformats.org/drawingml/2006/main" r:embed="R3f985fb924b644c7"/>
           <a:stretch xmlns:a="http://schemas.openxmlformats.org/drawingml/2006/main"/>
         </p:blipFill>
         <p:spPr>
@@ -4860,6 +4910,7 @@
           <a:lstStyle xmlns:a="http://schemas.openxmlformats.org/drawingml/2006/main"/>
           <a:p xmlns:a="http://schemas.openxmlformats.org/drawingml/2006/main">
             <a:pPr algn="ctr">
+              <a:buNone/>
               <a:defRPr sz="1350" b="0">
                 <a:solidFill>
                   <a:srgbClr val="5B677A"/>
@@ -4910,6 +4961,7 @@
           <a:lstStyle xmlns:a="http://schemas.openxmlformats.org/drawingml/2006/main"/>
           <a:p xmlns:a="http://schemas.openxmlformats.org/drawingml/2006/main">
             <a:pPr algn="ctr">
+              <a:buNone/>
               <a:defRPr sz="2025" b="1">
                 <a:solidFill>
                   <a:srgbClr val="2563EB"/>
@@ -4960,6 +5012,7 @@
           <a:lstStyle xmlns:a="http://schemas.openxmlformats.org/drawingml/2006/main"/>
           <a:p xmlns:a="http://schemas.openxmlformats.org/drawingml/2006/main">
             <a:pPr algn="l">
+              <a:buNone/>
               <a:defRPr sz="825" b="0">
                 <a:solidFill>
                   <a:srgbClr val="8490A3"/>
@@ -5010,6 +5063,7 @@
           <a:lstStyle xmlns:a="http://schemas.openxmlformats.org/drawingml/2006/main"/>
           <a:p xmlns:a="http://schemas.openxmlformats.org/drawingml/2006/main">
             <a:pPr algn="r">
+              <a:buNone/>
               <a:defRPr sz="825" b="0">
                 <a:solidFill>
                   <a:srgbClr val="8490A3"/>
@@ -5089,6 +5143,7 @@
           <a:lstStyle xmlns:a="http://schemas.openxmlformats.org/drawingml/2006/main"/>
           <a:p xmlns:a="http://schemas.openxmlformats.org/drawingml/2006/main">
             <a:pPr algn="l">
+              <a:buNone/>
               <a:defRPr sz="975" b="1">
                 <a:solidFill>
                   <a:srgbClr val="7C3AED"/>
@@ -5139,6 +5194,7 @@
           <a:lstStyle xmlns:a="http://schemas.openxmlformats.org/drawingml/2006/main"/>
           <a:p xmlns:a="http://schemas.openxmlformats.org/drawingml/2006/main">
             <a:pPr algn="l">
+              <a:buNone/>
               <a:defRPr sz="2700" b="1">
                 <a:solidFill>
                   <a:srgbClr val="0F172A"/>
@@ -5220,6 +5276,7 @@
           <a:lstStyle xmlns:a="http://schemas.openxmlformats.org/drawingml/2006/main"/>
           <a:p xmlns:a="http://schemas.openxmlformats.org/drawingml/2006/main">
             <a:pPr algn="l">
+              <a:buNone/>
               <a:defRPr sz="3900" b="1">
                 <a:solidFill>
                   <a:srgbClr val="15803D"/>
@@ -5270,6 +5327,7 @@
           <a:lstStyle xmlns:a="http://schemas.openxmlformats.org/drawingml/2006/main"/>
           <a:p xmlns:a="http://schemas.openxmlformats.org/drawingml/2006/main">
             <a:pPr algn="l">
+              <a:buNone/>
               <a:defRPr sz="1425" b="0">
                 <a:solidFill>
                   <a:srgbClr val="5B677A"/>
@@ -5320,6 +5378,7 @@
           <a:lstStyle xmlns:a="http://schemas.openxmlformats.org/drawingml/2006/main"/>
           <a:p xmlns:a="http://schemas.openxmlformats.org/drawingml/2006/main">
             <a:pPr algn="l">
+              <a:buNone/>
               <a:defRPr sz="3900" b="1">
                 <a:solidFill>
                   <a:srgbClr val="7C3AED"/>
@@ -5370,6 +5429,7 @@
           <a:lstStyle xmlns:a="http://schemas.openxmlformats.org/drawingml/2006/main"/>
           <a:p xmlns:a="http://schemas.openxmlformats.org/drawingml/2006/main">
             <a:pPr algn="l">
+              <a:buNone/>
               <a:defRPr sz="1425" b="0">
                 <a:solidFill>
                   <a:srgbClr val="5B677A"/>
@@ -5420,6 +5480,7 @@
           <a:lstStyle xmlns:a="http://schemas.openxmlformats.org/drawingml/2006/main"/>
           <a:p xmlns:a="http://schemas.openxmlformats.org/drawingml/2006/main">
             <a:pPr algn="l">
+              <a:buNone/>
               <a:defRPr sz="3900" b="1">
                 <a:solidFill>
                   <a:srgbClr val="2563EB"/>
@@ -5470,6 +5531,7 @@
           <a:lstStyle xmlns:a="http://schemas.openxmlformats.org/drawingml/2006/main"/>
           <a:p xmlns:a="http://schemas.openxmlformats.org/drawingml/2006/main">
             <a:pPr algn="l">
+              <a:buNone/>
               <a:defRPr sz="1425" b="0">
                 <a:solidFill>
                   <a:srgbClr val="5B677A"/>
@@ -5551,6 +5613,7 @@
           <a:lstStyle xmlns:a="http://schemas.openxmlformats.org/drawingml/2006/main"/>
           <a:p xmlns:a="http://schemas.openxmlformats.org/drawingml/2006/main">
             <a:pPr algn="l">
+              <a:buNone/>
               <a:defRPr sz="1275" b="1">
                 <a:solidFill>
                   <a:srgbClr val="5B677A"/>
@@ -5601,6 +5664,7 @@
           <a:lstStyle xmlns:a="http://schemas.openxmlformats.org/drawingml/2006/main"/>
           <a:p xmlns:a="http://schemas.openxmlformats.org/drawingml/2006/main">
             <a:pPr algn="l">
+              <a:buNone/>
               <a:defRPr sz="1275" b="1">
                 <a:solidFill>
                   <a:srgbClr val="5B677A"/>
@@ -5651,6 +5715,7 @@
           <a:lstStyle xmlns:a="http://schemas.openxmlformats.org/drawingml/2006/main"/>
           <a:p xmlns:a="http://schemas.openxmlformats.org/drawingml/2006/main">
             <a:pPr algn="l">
+              <a:buNone/>
               <a:defRPr sz="1275" b="1">
                 <a:solidFill>
                   <a:srgbClr val="5B677A"/>
@@ -5701,6 +5766,7 @@
           <a:lstStyle xmlns:a="http://schemas.openxmlformats.org/drawingml/2006/main"/>
           <a:p xmlns:a="http://schemas.openxmlformats.org/drawingml/2006/main">
             <a:pPr algn="l">
+              <a:buNone/>
               <a:defRPr sz="1275" b="1">
                 <a:solidFill>
                   <a:srgbClr val="5B677A"/>
@@ -5751,6 +5817,7 @@
           <a:lstStyle xmlns:a="http://schemas.openxmlformats.org/drawingml/2006/main"/>
           <a:p xmlns:a="http://schemas.openxmlformats.org/drawingml/2006/main">
             <a:pPr algn="l">
+              <a:buNone/>
               <a:defRPr sz="1275" b="1">
                 <a:solidFill>
                   <a:srgbClr val="5B677A"/>
@@ -5801,6 +5868,7 @@
           <a:lstStyle xmlns:a="http://schemas.openxmlformats.org/drawingml/2006/main"/>
           <a:p xmlns:a="http://schemas.openxmlformats.org/drawingml/2006/main">
             <a:pPr algn="l">
+              <a:buNone/>
               <a:defRPr sz="1275" b="1">
                 <a:solidFill>
                   <a:srgbClr val="5B677A"/>
@@ -5882,6 +5950,7 @@
           <a:lstStyle xmlns:a="http://schemas.openxmlformats.org/drawingml/2006/main"/>
           <a:p xmlns:a="http://schemas.openxmlformats.org/drawingml/2006/main">
             <a:pPr algn="l">
+              <a:buNone/>
               <a:defRPr sz="1350" b="0">
                 <a:solidFill>
                   <a:srgbClr val="0F172A"/>
@@ -5932,6 +6001,7 @@
           <a:lstStyle xmlns:a="http://schemas.openxmlformats.org/drawingml/2006/main"/>
           <a:p xmlns:a="http://schemas.openxmlformats.org/drawingml/2006/main">
             <a:pPr algn="l">
+              <a:buNone/>
               <a:defRPr sz="1350" b="0">
                 <a:solidFill>
                   <a:srgbClr val="0F172A"/>
@@ -5982,6 +6052,7 @@
           <a:lstStyle xmlns:a="http://schemas.openxmlformats.org/drawingml/2006/main"/>
           <a:p xmlns:a="http://schemas.openxmlformats.org/drawingml/2006/main">
             <a:pPr algn="l">
+              <a:buNone/>
               <a:defRPr sz="1350" b="0">
                 <a:solidFill>
                   <a:srgbClr val="0F172A"/>
@@ -6032,6 +6103,7 @@
           <a:lstStyle xmlns:a="http://schemas.openxmlformats.org/drawingml/2006/main"/>
           <a:p xmlns:a="http://schemas.openxmlformats.org/drawingml/2006/main">
             <a:pPr algn="l">
+              <a:buNone/>
               <a:defRPr sz="1350" b="0">
                 <a:solidFill>
                   <a:srgbClr val="0F172A"/>
@@ -6082,6 +6154,7 @@
           <a:lstStyle xmlns:a="http://schemas.openxmlformats.org/drawingml/2006/main"/>
           <a:p xmlns:a="http://schemas.openxmlformats.org/drawingml/2006/main">
             <a:pPr algn="l">
+              <a:buNone/>
               <a:defRPr sz="1350" b="1">
                 <a:solidFill>
                   <a:srgbClr val="7C3AED"/>
@@ -6132,6 +6205,7 @@
           <a:lstStyle xmlns:a="http://schemas.openxmlformats.org/drawingml/2006/main"/>
           <a:p xmlns:a="http://schemas.openxmlformats.org/drawingml/2006/main">
             <a:pPr algn="l">
+              <a:buNone/>
               <a:defRPr sz="1350" b="1">
                 <a:solidFill>
                   <a:srgbClr val="7C3AED"/>
@@ -6213,6 +6287,7 @@
           <a:lstStyle xmlns:a="http://schemas.openxmlformats.org/drawingml/2006/main"/>
           <a:p xmlns:a="http://schemas.openxmlformats.org/drawingml/2006/main">
             <a:pPr algn="l">
+              <a:buNone/>
               <a:defRPr sz="1350" b="0">
                 <a:solidFill>
                   <a:srgbClr val="0F172A"/>
@@ -6263,6 +6338,7 @@
           <a:lstStyle xmlns:a="http://schemas.openxmlformats.org/drawingml/2006/main"/>
           <a:p xmlns:a="http://schemas.openxmlformats.org/drawingml/2006/main">
             <a:pPr algn="l">
+              <a:buNone/>
               <a:defRPr sz="1350" b="0">
                 <a:solidFill>
                   <a:srgbClr val="0F172A"/>
@@ -6313,6 +6389,7 @@
           <a:lstStyle xmlns:a="http://schemas.openxmlformats.org/drawingml/2006/main"/>
           <a:p xmlns:a="http://schemas.openxmlformats.org/drawingml/2006/main">
             <a:pPr algn="l">
+              <a:buNone/>
               <a:defRPr sz="1350" b="0">
                 <a:solidFill>
                   <a:srgbClr val="0F172A"/>
@@ -6363,6 +6440,7 @@
           <a:lstStyle xmlns:a="http://schemas.openxmlformats.org/drawingml/2006/main"/>
           <a:p xmlns:a="http://schemas.openxmlformats.org/drawingml/2006/main">
             <a:pPr algn="l">
+              <a:buNone/>
               <a:defRPr sz="1350" b="0">
                 <a:solidFill>
                   <a:srgbClr val="0F172A"/>
@@ -6413,6 +6491,7 @@
           <a:lstStyle xmlns:a="http://schemas.openxmlformats.org/drawingml/2006/main"/>
           <a:p xmlns:a="http://schemas.openxmlformats.org/drawingml/2006/main">
             <a:pPr algn="l">
+              <a:buNone/>
               <a:defRPr sz="1350" b="1">
                 <a:solidFill>
                   <a:srgbClr val="7C3AED"/>
@@ -6463,6 +6542,7 @@
           <a:lstStyle xmlns:a="http://schemas.openxmlformats.org/drawingml/2006/main"/>
           <a:p xmlns:a="http://schemas.openxmlformats.org/drawingml/2006/main">
             <a:pPr algn="l">
+              <a:buNone/>
               <a:defRPr sz="1350" b="1">
                 <a:solidFill>
                   <a:srgbClr val="7C3AED"/>
@@ -6513,6 +6593,7 @@
           <a:lstStyle xmlns:a="http://schemas.openxmlformats.org/drawingml/2006/main"/>
           <a:p xmlns:a="http://schemas.openxmlformats.org/drawingml/2006/main">
             <a:pPr algn="l">
+              <a:buNone/>
               <a:defRPr sz="1350" b="0">
                 <a:solidFill>
                   <a:srgbClr val="0F172A"/>
@@ -6563,6 +6644,7 @@
           <a:lstStyle xmlns:a="http://schemas.openxmlformats.org/drawingml/2006/main"/>
           <a:p xmlns:a="http://schemas.openxmlformats.org/drawingml/2006/main">
             <a:pPr algn="l">
+              <a:buNone/>
               <a:defRPr sz="1350" b="0">
                 <a:solidFill>
                   <a:srgbClr val="0F172A"/>
@@ -6613,6 +6695,7 @@
           <a:lstStyle xmlns:a="http://schemas.openxmlformats.org/drawingml/2006/main"/>
           <a:p xmlns:a="http://schemas.openxmlformats.org/drawingml/2006/main">
             <a:pPr algn="l">
+              <a:buNone/>
               <a:defRPr sz="1350" b="0">
                 <a:solidFill>
                   <a:srgbClr val="0F172A"/>
@@ -6663,6 +6746,7 @@
           <a:lstStyle xmlns:a="http://schemas.openxmlformats.org/drawingml/2006/main"/>
           <a:p xmlns:a="http://schemas.openxmlformats.org/drawingml/2006/main">
             <a:pPr algn="l">
+              <a:buNone/>
               <a:defRPr sz="1350" b="0">
                 <a:solidFill>
                   <a:srgbClr val="0F172A"/>
@@ -6713,6 +6797,7 @@
           <a:lstStyle xmlns:a="http://schemas.openxmlformats.org/drawingml/2006/main"/>
           <a:p xmlns:a="http://schemas.openxmlformats.org/drawingml/2006/main">
             <a:pPr algn="l">
+              <a:buNone/>
               <a:defRPr sz="1350" b="0">
                 <a:solidFill>
                   <a:srgbClr val="0F172A"/>
@@ -6763,6 +6848,7 @@
           <a:lstStyle xmlns:a="http://schemas.openxmlformats.org/drawingml/2006/main"/>
           <a:p xmlns:a="http://schemas.openxmlformats.org/drawingml/2006/main">
             <a:pPr algn="l">
+              <a:buNone/>
               <a:defRPr sz="1350" b="0">
                 <a:solidFill>
                   <a:srgbClr val="0F172A"/>
@@ -6813,6 +6899,7 @@
           <a:lstStyle xmlns:a="http://schemas.openxmlformats.org/drawingml/2006/main"/>
           <a:p xmlns:a="http://schemas.openxmlformats.org/drawingml/2006/main">
             <a:pPr algn="r">
+              <a:buNone/>
               <a:defRPr sz="1125" b="0">
                 <a:solidFill>
                   <a:srgbClr val="5B677A"/>
@@ -6863,6 +6950,7 @@
           <a:lstStyle xmlns:a="http://schemas.openxmlformats.org/drawingml/2006/main"/>
           <a:p xmlns:a="http://schemas.openxmlformats.org/drawingml/2006/main">
             <a:pPr algn="l">
+              <a:buNone/>
               <a:defRPr sz="825" b="0">
                 <a:solidFill>
                   <a:srgbClr val="8490A3"/>
@@ -6913,6 +7001,7 @@
           <a:lstStyle xmlns:a="http://schemas.openxmlformats.org/drawingml/2006/main"/>
           <a:p xmlns:a="http://schemas.openxmlformats.org/drawingml/2006/main">
             <a:pPr algn="r">
+              <a:buNone/>
               <a:defRPr sz="825" b="0">
                 <a:solidFill>
                   <a:srgbClr val="8490A3"/>
@@ -6992,6 +7081,7 @@
           <a:lstStyle xmlns:a="http://schemas.openxmlformats.org/drawingml/2006/main"/>
           <a:p xmlns:a="http://schemas.openxmlformats.org/drawingml/2006/main">
             <a:pPr algn="l">
+              <a:buNone/>
               <a:defRPr sz="975" b="1">
                 <a:solidFill>
                   <a:srgbClr val="7C3AED"/>
@@ -7042,6 +7132,7 @@
           <a:lstStyle xmlns:a="http://schemas.openxmlformats.org/drawingml/2006/main"/>
           <a:p xmlns:a="http://schemas.openxmlformats.org/drawingml/2006/main">
             <a:pPr algn="l">
+              <a:buNone/>
               <a:defRPr sz="2700" b="1">
                 <a:solidFill>
                   <a:srgbClr val="0F172A"/>
@@ -7123,6 +7214,7 @@
           <a:lstStyle xmlns:a="http://schemas.openxmlformats.org/drawingml/2006/main"/>
           <a:p xmlns:a="http://schemas.openxmlformats.org/drawingml/2006/main">
             <a:pPr algn="l">
+              <a:buNone/>
               <a:defRPr sz="1500" b="1">
                 <a:solidFill>
                   <a:srgbClr val="5B677A"/>
@@ -7173,6 +7265,7 @@
           <a:lstStyle xmlns:a="http://schemas.openxmlformats.org/drawingml/2006/main"/>
           <a:p xmlns:a="http://schemas.openxmlformats.org/drawingml/2006/main">
             <a:pPr algn="l">
+              <a:buNone/>
               <a:defRPr sz="4350" b="1">
                 <a:solidFill>
                   <a:srgbClr val="15803D"/>
@@ -7223,6 +7316,7 @@
           <a:lstStyle xmlns:a="http://schemas.openxmlformats.org/drawingml/2006/main"/>
           <a:p xmlns:a="http://schemas.openxmlformats.org/drawingml/2006/main">
             <a:pPr algn="l">
+              <a:buNone/>
               <a:defRPr sz="1350" b="0">
                 <a:solidFill>
                   <a:srgbClr val="5B677A"/>
@@ -7273,6 +7367,7 @@
           <a:lstStyle xmlns:a="http://schemas.openxmlformats.org/drawingml/2006/main"/>
           <a:p xmlns:a="http://schemas.openxmlformats.org/drawingml/2006/main">
             <a:pPr algn="l">
+              <a:buNone/>
               <a:defRPr sz="1500" b="1">
                 <a:solidFill>
                   <a:srgbClr val="5B677A"/>
@@ -7323,6 +7418,7 @@
           <a:lstStyle xmlns:a="http://schemas.openxmlformats.org/drawingml/2006/main"/>
           <a:p xmlns:a="http://schemas.openxmlformats.org/drawingml/2006/main">
             <a:pPr algn="l">
+              <a:buNone/>
               <a:defRPr sz="4350" b="1">
                 <a:solidFill>
                   <a:srgbClr val="B45309"/>
@@ -7373,6 +7469,7 @@
           <a:lstStyle xmlns:a="http://schemas.openxmlformats.org/drawingml/2006/main"/>
           <a:p xmlns:a="http://schemas.openxmlformats.org/drawingml/2006/main">
             <a:pPr algn="l">
+              <a:buNone/>
               <a:defRPr sz="1350" b="0">
                 <a:solidFill>
                   <a:srgbClr val="B91C1C"/>
@@ -7423,6 +7520,7 @@
           <a:lstStyle xmlns:a="http://schemas.openxmlformats.org/drawingml/2006/main"/>
           <a:p xmlns:a="http://schemas.openxmlformats.org/drawingml/2006/main">
             <a:pPr algn="l">
+              <a:buNone/>
               <a:defRPr sz="1500" b="1">
                 <a:solidFill>
                   <a:srgbClr val="5B677A"/>
@@ -7473,6 +7571,7 @@
           <a:lstStyle xmlns:a="http://schemas.openxmlformats.org/drawingml/2006/main"/>
           <a:p xmlns:a="http://schemas.openxmlformats.org/drawingml/2006/main">
             <a:pPr algn="l">
+              <a:buNone/>
               <a:defRPr sz="2550" b="1">
                 <a:solidFill>
                   <a:srgbClr val="2563EB"/>
@@ -7523,6 +7622,7 @@
           <a:lstStyle xmlns:a="http://schemas.openxmlformats.org/drawingml/2006/main"/>
           <a:p xmlns:a="http://schemas.openxmlformats.org/drawingml/2006/main">
             <a:pPr algn="l">
+              <a:buNone/>
               <a:defRPr sz="1350" b="0">
                 <a:solidFill>
                   <a:srgbClr val="5B677A"/>
@@ -7604,6 +7704,7 @@
           <a:lstStyle xmlns:a="http://schemas.openxmlformats.org/drawingml/2006/main"/>
           <a:p xmlns:a="http://schemas.openxmlformats.org/drawingml/2006/main">
             <a:pPr algn="l">
+              <a:buNone/>
               <a:defRPr sz="1650" b="1">
                 <a:solidFill>
                   <a:srgbClr val="15803D"/>
@@ -7687,6 +7788,7 @@
           <a:lstStyle xmlns:a="http://schemas.openxmlformats.org/drawingml/2006/main"/>
           <a:p xmlns:a="http://schemas.openxmlformats.org/drawingml/2006/main">
             <a:pPr algn="l">
+              <a:buNone/>
               <a:defRPr sz="1575" b="0">
                 <a:solidFill>
                   <a:srgbClr val="0F172A"/>
@@ -7770,6 +7872,7 @@
           <a:lstStyle xmlns:a="http://schemas.openxmlformats.org/drawingml/2006/main"/>
           <a:p xmlns:a="http://schemas.openxmlformats.org/drawingml/2006/main">
             <a:pPr algn="l">
+              <a:buNone/>
               <a:defRPr sz="1575" b="0">
                 <a:solidFill>
                   <a:srgbClr val="0F172A"/>
@@ -7820,6 +7923,7 @@
           <a:lstStyle xmlns:a="http://schemas.openxmlformats.org/drawingml/2006/main"/>
           <a:p xmlns:a="http://schemas.openxmlformats.org/drawingml/2006/main">
             <a:pPr algn="l">
+              <a:buNone/>
               <a:defRPr sz="1650" b="1">
                 <a:solidFill>
                   <a:srgbClr val="B91C1C"/>
@@ -7903,6 +8007,7 @@
           <a:lstStyle xmlns:a="http://schemas.openxmlformats.org/drawingml/2006/main"/>
           <a:p xmlns:a="http://schemas.openxmlformats.org/drawingml/2006/main">
             <a:pPr algn="l">
+              <a:buNone/>
               <a:defRPr sz="1575" b="0">
                 <a:solidFill>
                   <a:srgbClr val="0F172A"/>
@@ -7986,6 +8091,7 @@
           <a:lstStyle xmlns:a="http://schemas.openxmlformats.org/drawingml/2006/main"/>
           <a:p xmlns:a="http://schemas.openxmlformats.org/drawingml/2006/main">
             <a:pPr algn="l">
+              <a:buNone/>
               <a:defRPr sz="1575" b="0">
                 <a:solidFill>
                   <a:srgbClr val="0F172A"/>
@@ -8036,6 +8142,7 @@
           <a:lstStyle xmlns:a="http://schemas.openxmlformats.org/drawingml/2006/main"/>
           <a:p xmlns:a="http://schemas.openxmlformats.org/drawingml/2006/main">
             <a:pPr algn="l">
+              <a:buNone/>
               <a:defRPr sz="825" b="0">
                 <a:solidFill>
                   <a:srgbClr val="8490A3"/>
@@ -8086,6 +8193,7 @@
           <a:lstStyle xmlns:a="http://schemas.openxmlformats.org/drawingml/2006/main"/>
           <a:p xmlns:a="http://schemas.openxmlformats.org/drawingml/2006/main">
             <a:pPr algn="r">
+              <a:buNone/>
               <a:defRPr sz="825" b="0">
                 <a:solidFill>
                   <a:srgbClr val="8490A3"/>
@@ -8165,6 +8273,7 @@
           <a:lstStyle xmlns:a="http://schemas.openxmlformats.org/drawingml/2006/main"/>
           <a:p xmlns:a="http://schemas.openxmlformats.org/drawingml/2006/main">
             <a:pPr algn="l">
+              <a:buNone/>
               <a:defRPr sz="975" b="1">
                 <a:solidFill>
                   <a:srgbClr val="7C3AED"/>
@@ -8215,6 +8324,7 @@
           <a:lstStyle xmlns:a="http://schemas.openxmlformats.org/drawingml/2006/main"/>
           <a:p xmlns:a="http://schemas.openxmlformats.org/drawingml/2006/main">
             <a:pPr algn="l">
+              <a:buNone/>
               <a:defRPr sz="2700" b="1">
                 <a:solidFill>
                   <a:srgbClr val="0F172A"/>
@@ -8265,14 +8375,14 @@
       </p:sp>
       <p:pic>
         <p:nvPicPr>
-          <p:cNvPr id="18" name=""/>
+          <p:cNvPr id="20" name=""/>
           <p:cNvPicPr>
             <a:picLocks xmlns:a="http://schemas.openxmlformats.org/drawingml/2006/main" noChangeAspect="1"/>
           </p:cNvPicPr>
           <p:nvPr/>
         </p:nvPicPr>
         <p:blipFill>
-          <a:blip xmlns:r="http://schemas.openxmlformats.org/officeDocument/2006/relationships" xmlns:a="http://schemas.openxmlformats.org/drawingml/2006/main" r:embed="R82401f3a20364b4c"/>
+          <a:blip xmlns:r="http://schemas.openxmlformats.org/officeDocument/2006/relationships" xmlns:a="http://schemas.openxmlformats.org/drawingml/2006/main" r:embed="R74a325f5e4024e9f"/>
           <a:stretch xmlns:a="http://schemas.openxmlformats.org/drawingml/2006/main"/>
         </p:blipFill>
         <p:spPr>
@@ -8318,6 +8428,7 @@
           <a:lstStyle xmlns:a="http://schemas.openxmlformats.org/drawingml/2006/main"/>
           <a:p xmlns:a="http://schemas.openxmlformats.org/drawingml/2006/main">
             <a:pPr algn="l">
+              <a:buNone/>
               <a:defRPr sz="1500" b="1">
                 <a:solidFill>
                   <a:srgbClr val="5B677A"/>
@@ -8368,6 +8479,7 @@
           <a:lstStyle xmlns:a="http://schemas.openxmlformats.org/drawingml/2006/main"/>
           <a:p xmlns:a="http://schemas.openxmlformats.org/drawingml/2006/main">
             <a:pPr algn="l">
+              <a:buNone/>
               <a:defRPr sz="3000" b="1">
                 <a:solidFill>
                   <a:srgbClr val="7C3AED"/>
@@ -8385,6 +8497,7 @@
           </a:p>
           <a:p xmlns:a="http://schemas.openxmlformats.org/drawingml/2006/main">
             <a:pPr algn="l">
+              <a:buNone/>
               <a:defRPr sz="3000" b="1">
                 <a:solidFill>
                   <a:srgbClr val="7C3AED"/>
@@ -8468,6 +8581,7 @@
           <a:lstStyle xmlns:a="http://schemas.openxmlformats.org/drawingml/2006/main"/>
           <a:p xmlns:a="http://schemas.openxmlformats.org/drawingml/2006/main">
             <a:pPr algn="l">
+              <a:buNone/>
               <a:defRPr sz="1500" b="0">
                 <a:solidFill>
                   <a:srgbClr val="0F172A"/>
@@ -8551,6 +8665,7 @@
           <a:lstStyle xmlns:a="http://schemas.openxmlformats.org/drawingml/2006/main"/>
           <a:p xmlns:a="http://schemas.openxmlformats.org/drawingml/2006/main">
             <a:pPr algn="l">
+              <a:buNone/>
               <a:defRPr sz="1500" b="0">
                 <a:solidFill>
                   <a:srgbClr val="0F172A"/>
@@ -8634,6 +8749,7 @@
           <a:lstStyle xmlns:a="http://schemas.openxmlformats.org/drawingml/2006/main"/>
           <a:p xmlns:a="http://schemas.openxmlformats.org/drawingml/2006/main">
             <a:pPr algn="l">
+              <a:buNone/>
               <a:defRPr sz="1500" b="0">
                 <a:solidFill>
                   <a:srgbClr val="0F172A"/>
@@ -8684,6 +8800,7 @@
           <a:lstStyle xmlns:a="http://schemas.openxmlformats.org/drawingml/2006/main"/>
           <a:p xmlns:a="http://schemas.openxmlformats.org/drawingml/2006/main">
             <a:pPr algn="l">
+              <a:buNone/>
               <a:defRPr sz="825" b="0">
                 <a:solidFill>
                   <a:srgbClr val="8490A3"/>
@@ -8734,6 +8851,7 @@
           <a:lstStyle xmlns:a="http://schemas.openxmlformats.org/drawingml/2006/main"/>
           <a:p xmlns:a="http://schemas.openxmlformats.org/drawingml/2006/main">
             <a:pPr algn="r">
+              <a:buNone/>
               <a:defRPr sz="825" b="0">
                 <a:solidFill>
                   <a:srgbClr val="8490A3"/>
@@ -8813,6 +8931,7 @@
           <a:lstStyle xmlns:a="http://schemas.openxmlformats.org/drawingml/2006/main"/>
           <a:p xmlns:a="http://schemas.openxmlformats.org/drawingml/2006/main">
             <a:pPr algn="l">
+              <a:buNone/>
               <a:defRPr sz="975" b="1">
                 <a:solidFill>
                   <a:srgbClr val="7C3AED"/>
@@ -8863,6 +8982,7 @@
           <a:lstStyle xmlns:a="http://schemas.openxmlformats.org/drawingml/2006/main"/>
           <a:p xmlns:a="http://schemas.openxmlformats.org/drawingml/2006/main">
             <a:pPr algn="l">
+              <a:buNone/>
               <a:defRPr sz="2700" b="1">
                 <a:solidFill>
                   <a:srgbClr val="0F172A"/>
@@ -8944,6 +9064,7 @@
           <a:lstStyle xmlns:a="http://schemas.openxmlformats.org/drawingml/2006/main"/>
           <a:p xmlns:a="http://schemas.openxmlformats.org/drawingml/2006/main">
             <a:pPr algn="l">
+              <a:buNone/>
               <a:defRPr sz="1425" b="1">
                 <a:solidFill>
                   <a:srgbClr val="0F172A"/>
@@ -8994,6 +9115,7 @@
           <a:lstStyle xmlns:a="http://schemas.openxmlformats.org/drawingml/2006/main"/>
           <a:p xmlns:a="http://schemas.openxmlformats.org/drawingml/2006/main">
             <a:pPr algn="l">
+              <a:buNone/>
               <a:defRPr sz="1425" b="1">
                 <a:solidFill>
                   <a:srgbClr val="0F172A"/>
@@ -9044,6 +9166,7 @@
           <a:lstStyle xmlns:a="http://schemas.openxmlformats.org/drawingml/2006/main"/>
           <a:p xmlns:a="http://schemas.openxmlformats.org/drawingml/2006/main">
             <a:pPr algn="l">
+              <a:buNone/>
               <a:defRPr sz="1425" b="1">
                 <a:solidFill>
                   <a:srgbClr val="0F172A"/>
@@ -9125,6 +9248,7 @@
           <a:lstStyle xmlns:a="http://schemas.openxmlformats.org/drawingml/2006/main"/>
           <a:p xmlns:a="http://schemas.openxmlformats.org/drawingml/2006/main">
             <a:pPr algn="l">
+              <a:buNone/>
               <a:defRPr sz="1425" b="1">
                 <a:solidFill>
                   <a:srgbClr val="7C3AED"/>
@@ -9206,6 +9330,7 @@
           <a:lstStyle xmlns:a="http://schemas.openxmlformats.org/drawingml/2006/main"/>
           <a:p xmlns:a="http://schemas.openxmlformats.org/drawingml/2006/main">
             <a:pPr algn="l">
+              <a:buNone/>
               <a:defRPr sz="1275" b="1">
                 <a:solidFill>
                   <a:srgbClr val="5B677A"/>
@@ -9256,6 +9381,7 @@
           <a:lstStyle xmlns:a="http://schemas.openxmlformats.org/drawingml/2006/main"/>
           <a:p xmlns:a="http://schemas.openxmlformats.org/drawingml/2006/main">
             <a:pPr algn="l">
+              <a:buNone/>
               <a:defRPr sz="1350" b="0">
                 <a:solidFill>
                   <a:srgbClr val="0F172A"/>
@@ -9306,6 +9432,7 @@
           <a:lstStyle xmlns:a="http://schemas.openxmlformats.org/drawingml/2006/main"/>
           <a:p xmlns:a="http://schemas.openxmlformats.org/drawingml/2006/main">
             <a:pPr algn="l">
+              <a:buNone/>
               <a:defRPr sz="1350" b="0">
                 <a:solidFill>
                   <a:srgbClr val="0F172A"/>
@@ -9356,6 +9483,7 @@
           <a:lstStyle xmlns:a="http://schemas.openxmlformats.org/drawingml/2006/main"/>
           <a:p xmlns:a="http://schemas.openxmlformats.org/drawingml/2006/main">
             <a:pPr algn="l">
+              <a:buNone/>
               <a:defRPr sz="1350" b="1">
                 <a:solidFill>
                   <a:srgbClr val="7C3AED"/>
@@ -9437,6 +9565,7 @@
           <a:lstStyle xmlns:a="http://schemas.openxmlformats.org/drawingml/2006/main"/>
           <a:p xmlns:a="http://schemas.openxmlformats.org/drawingml/2006/main">
             <a:pPr algn="l">
+              <a:buNone/>
               <a:defRPr sz="1275" b="1">
                 <a:solidFill>
                   <a:srgbClr val="5B677A"/>
@@ -9487,6 +9616,7 @@
           <a:lstStyle xmlns:a="http://schemas.openxmlformats.org/drawingml/2006/main"/>
           <a:p xmlns:a="http://schemas.openxmlformats.org/drawingml/2006/main">
             <a:pPr algn="l">
+              <a:buNone/>
               <a:defRPr sz="1350" b="0">
                 <a:solidFill>
                   <a:srgbClr val="0F172A"/>
@@ -9537,6 +9667,7 @@
           <a:lstStyle xmlns:a="http://schemas.openxmlformats.org/drawingml/2006/main"/>
           <a:p xmlns:a="http://schemas.openxmlformats.org/drawingml/2006/main">
             <a:pPr algn="l">
+              <a:buNone/>
               <a:defRPr sz="1350" b="0">
                 <a:solidFill>
                   <a:srgbClr val="0F172A"/>
@@ -9587,6 +9718,7 @@
           <a:lstStyle xmlns:a="http://schemas.openxmlformats.org/drawingml/2006/main"/>
           <a:p xmlns:a="http://schemas.openxmlformats.org/drawingml/2006/main">
             <a:pPr algn="l">
+              <a:buNone/>
               <a:defRPr sz="1350" b="1">
                 <a:solidFill>
                   <a:srgbClr val="7C3AED"/>
@@ -9668,6 +9800,7 @@
           <a:lstStyle xmlns:a="http://schemas.openxmlformats.org/drawingml/2006/main"/>
           <a:p xmlns:a="http://schemas.openxmlformats.org/drawingml/2006/main">
             <a:pPr algn="l">
+              <a:buNone/>
               <a:defRPr sz="1275" b="1">
                 <a:solidFill>
                   <a:srgbClr val="5B677A"/>
@@ -9718,6 +9851,7 @@
           <a:lstStyle xmlns:a="http://schemas.openxmlformats.org/drawingml/2006/main"/>
           <a:p xmlns:a="http://schemas.openxmlformats.org/drawingml/2006/main">
             <a:pPr algn="l">
+              <a:buNone/>
               <a:defRPr sz="1350" b="0">
                 <a:solidFill>
                   <a:srgbClr val="0F172A"/>
@@ -9768,6 +9902,7 @@
           <a:lstStyle xmlns:a="http://schemas.openxmlformats.org/drawingml/2006/main"/>
           <a:p xmlns:a="http://schemas.openxmlformats.org/drawingml/2006/main">
             <a:pPr algn="l">
+              <a:buNone/>
               <a:defRPr sz="1350" b="0">
                 <a:solidFill>
                   <a:srgbClr val="0F172A"/>
@@ -9818,6 +9953,7 @@
           <a:lstStyle xmlns:a="http://schemas.openxmlformats.org/drawingml/2006/main"/>
           <a:p xmlns:a="http://schemas.openxmlformats.org/drawingml/2006/main">
             <a:pPr algn="l">
+              <a:buNone/>
               <a:defRPr sz="1350" b="1">
                 <a:solidFill>
                   <a:srgbClr val="7C3AED"/>
@@ -9899,6 +10035,7 @@
           <a:lstStyle xmlns:a="http://schemas.openxmlformats.org/drawingml/2006/main"/>
           <a:p xmlns:a="http://schemas.openxmlformats.org/drawingml/2006/main">
             <a:pPr algn="l">
+              <a:buNone/>
               <a:defRPr sz="1275" b="1">
                 <a:solidFill>
                   <a:srgbClr val="5B677A"/>
@@ -9949,6 +10086,7 @@
           <a:lstStyle xmlns:a="http://schemas.openxmlformats.org/drawingml/2006/main"/>
           <a:p xmlns:a="http://schemas.openxmlformats.org/drawingml/2006/main">
             <a:pPr algn="l">
+              <a:buNone/>
               <a:defRPr sz="1350" b="0">
                 <a:solidFill>
                   <a:srgbClr val="0F172A"/>
@@ -9999,6 +10137,7 @@
           <a:lstStyle xmlns:a="http://schemas.openxmlformats.org/drawingml/2006/main"/>
           <a:p xmlns:a="http://schemas.openxmlformats.org/drawingml/2006/main">
             <a:pPr algn="l">
+              <a:buNone/>
               <a:defRPr sz="1350" b="0">
                 <a:solidFill>
                   <a:srgbClr val="0F172A"/>
@@ -10049,6 +10188,7 @@
           <a:lstStyle xmlns:a="http://schemas.openxmlformats.org/drawingml/2006/main"/>
           <a:p xmlns:a="http://schemas.openxmlformats.org/drawingml/2006/main">
             <a:pPr algn="l">
+              <a:buNone/>
               <a:defRPr sz="1350" b="1">
                 <a:solidFill>
                   <a:srgbClr val="7C3AED"/>
@@ -10130,6 +10270,7 @@
           <a:lstStyle xmlns:a="http://schemas.openxmlformats.org/drawingml/2006/main"/>
           <a:p xmlns:a="http://schemas.openxmlformats.org/drawingml/2006/main">
             <a:pPr algn="l">
+              <a:buNone/>
               <a:defRPr sz="1275" b="1">
                 <a:solidFill>
                   <a:srgbClr val="5B677A"/>
@@ -10180,6 +10321,7 @@
           <a:lstStyle xmlns:a="http://schemas.openxmlformats.org/drawingml/2006/main"/>
           <a:p xmlns:a="http://schemas.openxmlformats.org/drawingml/2006/main">
             <a:pPr algn="l">
+              <a:buNone/>
               <a:defRPr sz="1350" b="0">
                 <a:solidFill>
                   <a:srgbClr val="0F172A"/>
@@ -10230,6 +10372,7 @@
           <a:lstStyle xmlns:a="http://schemas.openxmlformats.org/drawingml/2006/main"/>
           <a:p xmlns:a="http://schemas.openxmlformats.org/drawingml/2006/main">
             <a:pPr algn="l">
+              <a:buNone/>
               <a:defRPr sz="1350" b="0">
                 <a:solidFill>
                   <a:srgbClr val="0F172A"/>
@@ -10280,6 +10423,7 @@
           <a:lstStyle xmlns:a="http://schemas.openxmlformats.org/drawingml/2006/main"/>
           <a:p xmlns:a="http://schemas.openxmlformats.org/drawingml/2006/main">
             <a:pPr algn="l">
+              <a:buNone/>
               <a:defRPr sz="1350" b="1">
                 <a:solidFill>
                   <a:srgbClr val="7C3AED"/>
@@ -10330,6 +10474,7 @@
           <a:lstStyle xmlns:a="http://schemas.openxmlformats.org/drawingml/2006/main"/>
           <a:p xmlns:a="http://schemas.openxmlformats.org/drawingml/2006/main">
             <a:pPr algn="r">
+              <a:buNone/>
               <a:defRPr sz="1050" b="0">
                 <a:solidFill>
                   <a:srgbClr val="5B677A"/>
@@ -10380,6 +10525,7 @@
           <a:lstStyle xmlns:a="http://schemas.openxmlformats.org/drawingml/2006/main"/>
           <a:p xmlns:a="http://schemas.openxmlformats.org/drawingml/2006/main">
             <a:pPr algn="l">
+              <a:buNone/>
               <a:defRPr sz="825" b="0">
                 <a:solidFill>
                   <a:srgbClr val="8490A3"/>
@@ -10430,6 +10576,7 @@
           <a:lstStyle xmlns:a="http://schemas.openxmlformats.org/drawingml/2006/main"/>
           <a:p xmlns:a="http://schemas.openxmlformats.org/drawingml/2006/main">
             <a:pPr algn="r">
+              <a:buNone/>
               <a:defRPr sz="825" b="0">
                 <a:solidFill>
                   <a:srgbClr val="8490A3"/>
@@ -10509,6 +10656,7 @@
           <a:lstStyle xmlns:a="http://schemas.openxmlformats.org/drawingml/2006/main"/>
           <a:p xmlns:a="http://schemas.openxmlformats.org/drawingml/2006/main">
             <a:pPr algn="l">
+              <a:buNone/>
               <a:defRPr sz="975" b="1">
                 <a:solidFill>
                   <a:srgbClr val="7C3AED"/>
@@ -10559,6 +10707,7 @@
           <a:lstStyle xmlns:a="http://schemas.openxmlformats.org/drawingml/2006/main"/>
           <a:p xmlns:a="http://schemas.openxmlformats.org/drawingml/2006/main">
             <a:pPr algn="l">
+              <a:buNone/>
               <a:defRPr sz="2700" b="1">
                 <a:solidFill>
                   <a:srgbClr val="0F172A"/>
@@ -10640,6 +10789,7 @@
           <a:lstStyle xmlns:a="http://schemas.openxmlformats.org/drawingml/2006/main"/>
           <a:p xmlns:a="http://schemas.openxmlformats.org/drawingml/2006/main">
             <a:pPr algn="l">
+              <a:buNone/>
               <a:defRPr sz="1875" b="1">
                 <a:solidFill>
                   <a:srgbClr val="15803D"/>
@@ -10723,6 +10873,7 @@
           <a:lstStyle xmlns:a="http://schemas.openxmlformats.org/drawingml/2006/main"/>
           <a:p xmlns:a="http://schemas.openxmlformats.org/drawingml/2006/main">
             <a:pPr algn="l">
+              <a:buNone/>
               <a:defRPr sz="1575" b="0">
                 <a:solidFill>
                   <a:srgbClr val="0F172A"/>
@@ -10806,6 +10957,7 @@
           <a:lstStyle xmlns:a="http://schemas.openxmlformats.org/drawingml/2006/main"/>
           <a:p xmlns:a="http://schemas.openxmlformats.org/drawingml/2006/main">
             <a:pPr algn="l">
+              <a:buNone/>
               <a:defRPr sz="1575" b="0">
                 <a:solidFill>
                   <a:srgbClr val="0F172A"/>
@@ -10889,6 +11041,7 @@
           <a:lstStyle xmlns:a="http://schemas.openxmlformats.org/drawingml/2006/main"/>
           <a:p xmlns:a="http://schemas.openxmlformats.org/drawingml/2006/main">
             <a:pPr algn="l">
+              <a:buNone/>
               <a:defRPr sz="1575" b="0">
                 <a:solidFill>
                   <a:srgbClr val="0F172A"/>
@@ -10972,6 +11125,7 @@
           <a:lstStyle xmlns:a="http://schemas.openxmlformats.org/drawingml/2006/main"/>
           <a:p xmlns:a="http://schemas.openxmlformats.org/drawingml/2006/main">
             <a:pPr algn="l">
+              <a:buNone/>
               <a:defRPr sz="1575" b="0">
                 <a:solidFill>
                   <a:srgbClr val="0F172A"/>
@@ -11053,6 +11207,7 @@
           <a:lstStyle xmlns:a="http://schemas.openxmlformats.org/drawingml/2006/main"/>
           <a:p xmlns:a="http://schemas.openxmlformats.org/drawingml/2006/main">
             <a:pPr algn="l">
+              <a:buNone/>
               <a:defRPr sz="1875" b="1">
                 <a:solidFill>
                   <a:srgbClr val="7C3AED"/>
@@ -11136,6 +11291,7 @@
           <a:lstStyle xmlns:a="http://schemas.openxmlformats.org/drawingml/2006/main"/>
           <a:p xmlns:a="http://schemas.openxmlformats.org/drawingml/2006/main">
             <a:pPr algn="l">
+              <a:buNone/>
               <a:defRPr sz="1575" b="0">
                 <a:solidFill>
                   <a:srgbClr val="0F172A"/>
@@ -11219,6 +11375,7 @@
           <a:lstStyle xmlns:a="http://schemas.openxmlformats.org/drawingml/2006/main"/>
           <a:p xmlns:a="http://schemas.openxmlformats.org/drawingml/2006/main">
             <a:pPr algn="l">
+              <a:buNone/>
               <a:defRPr sz="1575" b="0">
                 <a:solidFill>
                   <a:srgbClr val="0F172A"/>
@@ -11302,6 +11459,7 @@
           <a:lstStyle xmlns:a="http://schemas.openxmlformats.org/drawingml/2006/main"/>
           <a:p xmlns:a="http://schemas.openxmlformats.org/drawingml/2006/main">
             <a:pPr algn="l">
+              <a:buNone/>
               <a:defRPr sz="1575" b="0">
                 <a:solidFill>
                   <a:srgbClr val="0F172A"/>
@@ -11352,6 +11510,7 @@
           <a:lstStyle xmlns:a="http://schemas.openxmlformats.org/drawingml/2006/main"/>
           <a:p xmlns:a="http://schemas.openxmlformats.org/drawingml/2006/main">
             <a:pPr algn="l">
+              <a:buNone/>
               <a:defRPr sz="1425" b="1">
                 <a:solidFill>
                   <a:srgbClr val="B91C1C"/>
@@ -11402,6 +11561,7 @@
           <a:lstStyle xmlns:a="http://schemas.openxmlformats.org/drawingml/2006/main"/>
           <a:p xmlns:a="http://schemas.openxmlformats.org/drawingml/2006/main">
             <a:pPr algn="l">
+              <a:buNone/>
               <a:defRPr sz="825" b="0">
                 <a:solidFill>
                   <a:srgbClr val="8490A3"/>
@@ -11452,6 +11612,7 @@
           <a:lstStyle xmlns:a="http://schemas.openxmlformats.org/drawingml/2006/main"/>
           <a:p xmlns:a="http://schemas.openxmlformats.org/drawingml/2006/main">
             <a:pPr algn="r">
+              <a:buNone/>
               <a:defRPr sz="825" b="0">
                 <a:solidFill>
                   <a:srgbClr val="8490A3"/>

</xml_diff>

<commit_message>
style: unify presentation text in black
</commit_message>
<xml_diff>
--- a/paper/presentation/KSC_PILOT_presentation.pptx
+++ b/paper/presentation/KSC_PILOT_presentation.pptx
@@ -2,22 +2,22 @@
 <file path=ppt/presentation.xml><?xml version="1.0" encoding="utf-8"?>
 <p:presentation xmlns:p="http://schemas.openxmlformats.org/presentationml/2006/main">
   <p:sldMasterIdLst>
-    <p:sldMasterId xmlns:r="http://schemas.openxmlformats.org/officeDocument/2006/relationships" id="2147483648" r:id="R1a0879dd590f46fd"/>
+    <p:sldMasterId xmlns:r="http://schemas.openxmlformats.org/officeDocument/2006/relationships" id="2147483648" r:id="Rf057dc6403a54a55"/>
   </p:sldMasterIdLst>
   <p:notesMasterIdLst>
-    <p:notesMasterId xmlns:r="http://schemas.openxmlformats.org/officeDocument/2006/relationships" r:id="R107ba4b628134595"/>
+    <p:notesMasterId xmlns:r="http://schemas.openxmlformats.org/officeDocument/2006/relationships" r:id="R2e3b437c5ccd4652"/>
   </p:notesMasterIdLst>
   <p:sldIdLst>
-    <p:sldId xmlns:r="http://schemas.openxmlformats.org/officeDocument/2006/relationships" id="256" r:id="R2b1297a6f28d420f"/>
-    <p:sldId xmlns:r="http://schemas.openxmlformats.org/officeDocument/2006/relationships" id="257" r:id="R0b6beab32b1b4140"/>
-    <p:sldId xmlns:r="http://schemas.openxmlformats.org/officeDocument/2006/relationships" id="258" r:id="Rd19b890e53f3457f"/>
-    <p:sldId xmlns:r="http://schemas.openxmlformats.org/officeDocument/2006/relationships" id="259" r:id="R9b3cc37d52f4434a"/>
-    <p:sldId xmlns:r="http://schemas.openxmlformats.org/officeDocument/2006/relationships" id="260" r:id="R821a8255da7d4579"/>
-    <p:sldId xmlns:r="http://schemas.openxmlformats.org/officeDocument/2006/relationships" id="261" r:id="R36c1ba71f66145b8"/>
-    <p:sldId xmlns:r="http://schemas.openxmlformats.org/officeDocument/2006/relationships" id="262" r:id="Rf4296e3f347544c4"/>
-    <p:sldId xmlns:r="http://schemas.openxmlformats.org/officeDocument/2006/relationships" id="263" r:id="R45ddfce14bbd4095"/>
-    <p:sldId xmlns:r="http://schemas.openxmlformats.org/officeDocument/2006/relationships" id="264" r:id="Rb71b29c8f24b4e74"/>
-    <p:sldId xmlns:r="http://schemas.openxmlformats.org/officeDocument/2006/relationships" id="265" r:id="R7b4d993fbfa04165"/>
+    <p:sldId xmlns:r="http://schemas.openxmlformats.org/officeDocument/2006/relationships" id="256" r:id="Reeb8c69ae7b04333"/>
+    <p:sldId xmlns:r="http://schemas.openxmlformats.org/officeDocument/2006/relationships" id="257" r:id="R419620c91bea460a"/>
+    <p:sldId xmlns:r="http://schemas.openxmlformats.org/officeDocument/2006/relationships" id="258" r:id="R3ed2c2b885014e85"/>
+    <p:sldId xmlns:r="http://schemas.openxmlformats.org/officeDocument/2006/relationships" id="259" r:id="R4992cd0540a2427c"/>
+    <p:sldId xmlns:r="http://schemas.openxmlformats.org/officeDocument/2006/relationships" id="260" r:id="Rac3c8e3756e845bd"/>
+    <p:sldId xmlns:r="http://schemas.openxmlformats.org/officeDocument/2006/relationships" id="261" r:id="Rca785370b9f74d12"/>
+    <p:sldId xmlns:r="http://schemas.openxmlformats.org/officeDocument/2006/relationships" id="262" r:id="Rc531a4192f4e4f71"/>
+    <p:sldId xmlns:r="http://schemas.openxmlformats.org/officeDocument/2006/relationships" id="263" r:id="Rc7d7062b4cf94941"/>
+    <p:sldId xmlns:r="http://schemas.openxmlformats.org/officeDocument/2006/relationships" id="264" r:id="Rca7bc90e824c4560"/>
+    <p:sldId xmlns:r="http://schemas.openxmlformats.org/officeDocument/2006/relationships" id="265" r:id="R23cfeaad201148be"/>
   </p:sldIdLst>
   <p:sldSz cx="12192000" cy="6858000"/>
   <p:notesSz cx="6858000" cy="9144000"/>
@@ -1369,7 +1369,7 @@
   </p:cSld>
   <p:clrMap bg1="lt1" tx1="dk1" bg2="lt2" tx2="dk2" accent1="accent1" accent2="accent2" accent3="accent3" accent4="accent4" accent5="accent5" accent6="accent6" hlink="hlink" folHlink="folHlink"/>
   <p:sldLayoutIdLst>
-    <p:sldLayoutId xmlns:r="http://schemas.openxmlformats.org/officeDocument/2006/relationships" id="2147483649" r:id="R2bf73a13f4fa458b"/>
+    <p:sldLayoutId xmlns:r="http://schemas.openxmlformats.org/officeDocument/2006/relationships" id="2147483649" r:id="Rd37ef73476924278"/>
   </p:sldLayoutIdLst>
   <p:txStyles>
     <p:titleStyle>
@@ -1989,25 +1989,25 @@
             <a:r>
               <a:rPr sz="3900" b="1">
                 <a:solidFill>
+                  <a:srgbClr val="000000"/>
+                </a:solidFill>
+              </a:rPr>
+              <a:t>작은 모델이 먼저 답하고,</a:t>
+            </a:r>
+          </a:p>
+          <a:p xmlns:a="http://schemas.openxmlformats.org/drawingml/2006/main">
+            <a:pPr algn="l">
+              <a:buNone/>
+              <a:defRPr sz="3900" b="1">
+                <a:solidFill>
                   <a:srgbClr val="0F172A"/>
                 </a:solidFill>
-              </a:rPr>
-              <a:t>작은 모델이 먼저 답하고,</a:t>
-            </a:r>
-          </a:p>
-          <a:p xmlns:a="http://schemas.openxmlformats.org/drawingml/2006/main">
-            <a:pPr algn="l">
-              <a:buNone/>
-              <a:defRPr sz="3900" b="1">
-                <a:solidFill>
-                  <a:srgbClr val="0F172A"/>
-                </a:solidFill>
               </a:defRPr>
             </a:pPr>
             <a:r>
               <a:rPr sz="3900" b="1">
                 <a:solidFill>
-                  <a:srgbClr val="0F172A"/>
+                  <a:srgbClr val="000000"/>
                 </a:solidFill>
               </a:rPr>
               <a:t>의심될 때만 큰 모델이 해결한다</a:t>
@@ -2058,7 +2058,7 @@
             <a:r>
               <a:rPr sz="1800" b="0">
                 <a:solidFill>
-                  <a:srgbClr val="5B677A"/>
+                  <a:srgbClr val="000000"/>
                 </a:solidFill>
               </a:rPr>
               <a:t>출력 신뢰도 + 정답 한 줄 검증을 이용한 적응형 SLM-LLM 라우팅</a:t>
@@ -2109,7 +2109,7 @@
             <a:r>
               <a:rPr sz="1275" b="1">
                 <a:solidFill>
-                  <a:srgbClr val="7C3AED"/>
+                  <a:srgbClr val="000000"/>
                 </a:solidFill>
               </a:rPr>
               <a:t>KSC PILOT · Capability-aware Adaptive Routing</a:t>
@@ -2160,7 +2160,7 @@
             <a:r>
               <a:rPr sz="3900" b="1">
                 <a:solidFill>
-                  <a:srgbClr val="2563EB"/>
+                  <a:srgbClr val="000000"/>
                 </a:solidFill>
               </a:rPr>
               <a:t>29.15 ms</a:t>
@@ -2211,7 +2211,7 @@
             <a:r>
               <a:rPr sz="1425" b="0">
                 <a:solidFill>
-                  <a:srgbClr val="5B677A"/>
+                  <a:srgbClr val="000000"/>
                 </a:solidFill>
               </a:rPr>
               <a:t>정답 전용 검증 지연시간</a:t>
@@ -2262,7 +2262,7 @@
             <a:r>
               <a:rPr sz="3900" b="1">
                 <a:solidFill>
-                  <a:srgbClr val="7C3AED"/>
+                  <a:srgbClr val="000000"/>
                 </a:solidFill>
               </a:rPr>
               <a:t>−94.09%</a:t>
@@ -2313,7 +2313,7 @@
             <a:r>
               <a:rPr sz="1425" b="0">
                 <a:solidFill>
-                  <a:srgbClr val="5B677A"/>
+                  <a:srgbClr val="000000"/>
                 </a:solidFill>
               </a:rPr>
               <a:t>두 번째 호출 지연시간</a:t>
@@ -2364,7 +2364,7 @@
             <a:r>
               <a:rPr sz="1500" b="1">
                 <a:solidFill>
-                  <a:srgbClr val="0F172A"/>
+                  <a:srgbClr val="000000"/>
                 </a:solidFill>
               </a:rPr>
               <a:t>Qwen2.5-1.5B → 필요할 때만 7B</a:t>
@@ -2415,7 +2415,7 @@
             <a:r>
               <a:rPr sz="825" b="0">
                 <a:solidFill>
-                  <a:srgbClr val="8490A3"/>
+                  <a:srgbClr val="000000"/>
                 </a:solidFill>
               </a:rPr>
               <a:t>Capability-aware Adaptive SLM-LLM Routing</a:t>
@@ -2466,7 +2466,7 @@
             <a:r>
               <a:rPr sz="825" b="0">
                 <a:solidFill>
-                  <a:srgbClr val="8490A3"/>
+                  <a:srgbClr val="000000"/>
                 </a:solidFill>
               </a:rPr>
               <a:t>01</a:t>
@@ -2546,7 +2546,7 @@
             <a:r>
               <a:rPr sz="1125" b="1">
                 <a:solidFill>
-                  <a:srgbClr val="7C3AED"/>
+                  <a:srgbClr val="000000"/>
                 </a:solidFill>
               </a:rPr>
               <a:t>결론</a:t>
@@ -2597,25 +2597,25 @@
             <a:r>
               <a:rPr sz="3900" b="1">
                 <a:solidFill>
+                  <a:srgbClr val="000000"/>
+                </a:solidFill>
+              </a:rPr>
+              <a:t>긴 재풀이 없이도</a:t>
+            </a:r>
+          </a:p>
+          <a:p xmlns:a="http://schemas.openxmlformats.org/drawingml/2006/main">
+            <a:pPr algn="l">
+              <a:buNone/>
+              <a:defRPr sz="3900" b="1">
+                <a:solidFill>
                   <a:srgbClr val="0F172A"/>
                 </a:solidFill>
-              </a:rPr>
-              <a:t>긴 재풀이 없이도</a:t>
-            </a:r>
-          </a:p>
-          <a:p xmlns:a="http://schemas.openxmlformats.org/drawingml/2006/main">
-            <a:pPr algn="l">
-              <a:buNone/>
-              <a:defRPr sz="3900" b="1">
-                <a:solidFill>
-                  <a:srgbClr val="0F172A"/>
-                </a:solidFill>
               </a:defRPr>
             </a:pPr>
             <a:r>
               <a:rPr sz="3900" b="1">
                 <a:solidFill>
-                  <a:srgbClr val="0F172A"/>
+                  <a:srgbClr val="000000"/>
                 </a:solidFill>
               </a:rPr>
               <a:t>‘믿고 맡길 답’을 고를 수 있다</a:t>
@@ -2730,7 +2730,7 @@
             <a:r>
               <a:rPr sz="1725" b="0">
                 <a:solidFill>
-                  <a:srgbClr val="0F172A"/>
+                  <a:srgbClr val="000000"/>
                 </a:solidFill>
               </a:rPr>
               <a:t>29.15ms의 정답 전용 검증</a:t>
@@ -2814,7 +2814,7 @@
             <a:r>
               <a:rPr sz="1725" b="0">
                 <a:solidFill>
-                  <a:srgbClr val="0F172A"/>
+                  <a:srgbClr val="000000"/>
                 </a:solidFill>
               </a:rPr>
               <a:t>전체 비용 19.42~22.29% 절감</a:t>
@@ -2898,7 +2898,7 @@
             <a:r>
               <a:rPr sz="1725" b="0">
                 <a:solidFill>
-                  <a:srgbClr val="0F172A"/>
+                  <a:srgbClr val="000000"/>
                 </a:solidFill>
               </a:rPr>
               <a:t>안전 보장은 near-miss - 다음 독립 표본에서 재인증</a:t>
@@ -2949,7 +2949,7 @@
             <a:r>
               <a:rPr sz="1650" b="1">
                 <a:solidFill>
-                  <a:srgbClr val="5B677A"/>
+                  <a:srgbClr val="000000"/>
                 </a:solidFill>
               </a:rPr>
               <a:t>다음 단계</a:t>
@@ -3000,10 +3000,28 @@
             <a:r>
               <a:rPr sz="1725" b="1">
                 <a:solidFill>
+                  <a:srgbClr val="000000"/>
+                </a:solidFill>
+              </a:rPr>
+              <a:t>위험 제약 임계값 최적화</a:t>
+            </a:r>
+          </a:p>
+          <a:p xmlns:a="http://schemas.openxmlformats.org/drawingml/2006/main">
+            <a:pPr algn="l">
+              <a:buNone/>
+              <a:defRPr sz="1725" b="1">
+                <a:solidFill>
                   <a:srgbClr val="7C3AED"/>
                 </a:solidFill>
-              </a:rPr>
-              <a:t>위험 제약 임계값 최적화</a:t>
+              </a:defRPr>
+            </a:pPr>
+            <a:r>
+              <a:rPr sz="1725" b="1">
+                <a:solidFill>
+                  <a:srgbClr val="000000"/>
+                </a:solidFill>
+              </a:rPr>
+              <a:t>+ 더 큰 표본의 비열등성 검정</a:t>
             </a:r>
           </a:p>
           <a:p xmlns:a="http://schemas.openxmlformats.org/drawingml/2006/main">
@@ -3018,25 +3036,7 @@
             <a:r>
               <a:rPr sz="1725" b="1">
                 <a:solidFill>
-                  <a:srgbClr val="7C3AED"/>
-                </a:solidFill>
-              </a:rPr>
-              <a:t>+ 더 큰 표본의 비열등성 검정</a:t>
-            </a:r>
-          </a:p>
-          <a:p xmlns:a="http://schemas.openxmlformats.org/drawingml/2006/main">
-            <a:pPr algn="l">
-              <a:buNone/>
-              <a:defRPr sz="1725" b="1">
-                <a:solidFill>
-                  <a:srgbClr val="7C3AED"/>
-                </a:solidFill>
-              </a:defRPr>
-            </a:pPr>
-            <a:r>
-              <a:rPr sz="1725" b="1">
-                <a:solidFill>
-                  <a:srgbClr val="7C3AED"/>
+                  <a:srgbClr val="000000"/>
                 </a:solidFill>
               </a:rPr>
               <a:t>+ 다중 모델·도메인 검증</a:t>
@@ -3087,7 +3087,7 @@
             <a:r>
               <a:rPr sz="1275" b="0">
                 <a:solidFill>
-                  <a:srgbClr val="2563EB"/>
+                  <a:srgbClr val="000000"/>
                 </a:solidFill>
               </a:rPr>
               <a:t>코드·재현 자료: github.com/chjnett/llm_router</a:t>
@@ -3138,7 +3138,7 @@
             <a:r>
               <a:rPr sz="825" b="0">
                 <a:solidFill>
-                  <a:srgbClr val="8490A3"/>
+                  <a:srgbClr val="000000"/>
                 </a:solidFill>
               </a:rPr>
               <a:t>Capability-aware Adaptive SLM-LLM Routing</a:t>
@@ -3189,7 +3189,7 @@
             <a:r>
               <a:rPr sz="825" b="0">
                 <a:solidFill>
-                  <a:srgbClr val="8490A3"/>
+                  <a:srgbClr val="000000"/>
                 </a:solidFill>
               </a:rPr>
               <a:t>10</a:t>
@@ -3269,7 +3269,7 @@
             <a:r>
               <a:rPr sz="975" b="1">
                 <a:solidFill>
-                  <a:srgbClr val="7C3AED"/>
+                  <a:srgbClr val="000000"/>
                 </a:solidFill>
               </a:rPr>
               <a:t>KSC PILOT</a:t>
@@ -3320,7 +3320,7 @@
             <a:r>
               <a:rPr sz="2700" b="1">
                 <a:solidFill>
-                  <a:srgbClr val="0F172A"/>
+                  <a:srgbClr val="000000"/>
                 </a:solidFill>
               </a:rPr>
               <a:t>질문만 보면 ‘주제’는 알지만, 작은 모델의 ‘수행 가능성’은 모른다</a:t>
@@ -3402,7 +3402,7 @@
             <a:r>
               <a:rPr sz="1800" b="1">
                 <a:solidFill>
-                  <a:srgbClr val="5B677A"/>
+                  <a:srgbClr val="000000"/>
                 </a:solidFill>
               </a:rPr>
               <a:t>기존 Query-only 라우팅</a:t>
@@ -3453,7 +3453,7 @@
             <a:r>
               <a:rPr sz="1875" b="1">
                 <a:solidFill>
-                  <a:srgbClr val="0F172A"/>
+                  <a:srgbClr val="000000"/>
                 </a:solidFill>
               </a:rPr>
               <a:t>질문 임베딩</a:t>
@@ -3504,7 +3504,7 @@
             <a:r>
               <a:rPr sz="2100" b="1">
                 <a:solidFill>
-                  <a:srgbClr val="5B677A"/>
+                  <a:srgbClr val="000000"/>
                 </a:solidFill>
               </a:rPr>
               <a:t>→</a:t>
@@ -3555,7 +3555,7 @@
             <a:r>
               <a:rPr sz="1875" b="1">
                 <a:solidFill>
-                  <a:srgbClr val="0F172A"/>
+                  <a:srgbClr val="000000"/>
                 </a:solidFill>
               </a:rPr>
               <a:t>모델 선택</a:t>
@@ -3606,25 +3606,25 @@
             <a:r>
               <a:rPr sz="1725" b="0">
                 <a:solidFill>
+                  <a:srgbClr val="000000"/>
+                </a:solidFill>
+              </a:rPr>
+              <a:t>같은 수학 주제 안에서도</a:t>
+            </a:r>
+          </a:p>
+          <a:p xmlns:a="http://schemas.openxmlformats.org/drawingml/2006/main">
+            <a:pPr algn="l">
+              <a:buNone/>
+              <a:defRPr sz="1725" b="0">
+                <a:solidFill>
                   <a:srgbClr val="B91C1C"/>
                 </a:solidFill>
-              </a:rPr>
-              <a:t>같은 수학 주제 안에서도</a:t>
-            </a:r>
-          </a:p>
-          <a:p xmlns:a="http://schemas.openxmlformats.org/drawingml/2006/main">
-            <a:pPr algn="l">
-              <a:buNone/>
-              <a:defRPr sz="1725" b="0">
-                <a:solidFill>
-                  <a:srgbClr val="B91C1C"/>
-                </a:solidFill>
               </a:defRPr>
             </a:pPr>
             <a:r>
               <a:rPr sz="1725" b="0">
                 <a:solidFill>
-                  <a:srgbClr val="B91C1C"/>
+                  <a:srgbClr val="000000"/>
                 </a:solidFill>
               </a:rPr>
               <a:t>쉬운 문제와 어려운 문제를 구분하기 어렵다</a:t>
@@ -3706,7 +3706,7 @@
             <a:r>
               <a:rPr sz="1800" b="1">
                 <a:solidFill>
-                  <a:srgbClr val="7C3AED"/>
+                  <a:srgbClr val="000000"/>
                 </a:solidFill>
               </a:rPr>
               <a:t>본 연구: Output-aware</a:t>
@@ -3790,7 +3790,7 @@
             <a:r>
               <a:rPr sz="1650" b="0">
                 <a:solidFill>
-                  <a:srgbClr val="0F172A"/>
+                  <a:srgbClr val="000000"/>
                 </a:solidFill>
               </a:rPr>
               <a:t>SLM이 먼저 실제 답을 생성</a:t>
@@ -3874,7 +3874,7 @@
             <a:r>
               <a:rPr sz="1650" b="0">
                 <a:solidFill>
-                  <a:srgbClr val="0F172A"/>
+                  <a:srgbClr val="000000"/>
                 </a:solidFill>
               </a:rPr>
               <a:t>토큰 확률·엔트로피·형식 등 11개 특징 측정</a:t>
@@ -3958,7 +3958,7 @@
             <a:r>
               <a:rPr sz="1650" b="0">
                 <a:solidFill>
-                  <a:srgbClr val="0F172A"/>
+                  <a:srgbClr val="000000"/>
                 </a:solidFill>
               </a:rPr>
               <a:t>경계 사례만 정답 한 줄로 재검증</a:t>
@@ -4042,7 +4042,7 @@
             <a:r>
               <a:rPr sz="1650" b="0">
                 <a:solidFill>
-                  <a:srgbClr val="0F172A"/>
+                  <a:srgbClr val="000000"/>
                 </a:solidFill>
               </a:rPr>
               <a:t>불일치하거나 불확실할 때만 7B 호출</a:t>
@@ -4093,7 +4093,7 @@
             <a:r>
               <a:rPr sz="2400" b="1">
                 <a:solidFill>
-                  <a:srgbClr val="2563EB"/>
+                  <a:srgbClr val="000000"/>
                 </a:solidFill>
               </a:rPr>
               <a:t>AUC 0.589 → 0.722</a:t>
@@ -4144,7 +4144,7 @@
             <a:r>
               <a:rPr sz="825" b="0">
                 <a:solidFill>
-                  <a:srgbClr val="8490A3"/>
+                  <a:srgbClr val="000000"/>
                 </a:solidFill>
               </a:rPr>
               <a:t>Capability-aware Adaptive SLM-LLM Routing</a:t>
@@ -4195,7 +4195,7 @@
             <a:r>
               <a:rPr sz="825" b="0">
                 <a:solidFill>
-                  <a:srgbClr val="8490A3"/>
+                  <a:srgbClr val="000000"/>
                 </a:solidFill>
               </a:rPr>
               <a:t>02</a:t>
@@ -4275,7 +4275,7 @@
             <a:r>
               <a:rPr sz="975" b="1">
                 <a:solidFill>
-                  <a:srgbClr val="7C3AED"/>
+                  <a:srgbClr val="000000"/>
                 </a:solidFill>
               </a:rPr>
               <a:t>KSC PILOT</a:t>
@@ -4326,7 +4326,7 @@
             <a:r>
               <a:rPr sz="2700" b="1">
                 <a:solidFill>
-                  <a:srgbClr val="0F172A"/>
+                  <a:srgbClr val="000000"/>
                 </a:solidFill>
               </a:rPr>
               <a:t>한 번의 짧은 재검증이 Lower 채택과 Upper 전달을 가른다</a:t>
@@ -4374,7 +4374,7 @@
           <p:nvPr/>
         </p:nvPicPr>
         <p:blipFill>
-          <a:blip xmlns:r="http://schemas.openxmlformats.org/officeDocument/2006/relationships" xmlns:a="http://schemas.openxmlformats.org/drawingml/2006/main" r:embed="R5ddd54eca7fc4c2b"/>
+          <a:blip xmlns:r="http://schemas.openxmlformats.org/officeDocument/2006/relationships" xmlns:a="http://schemas.openxmlformats.org/drawingml/2006/main" r:embed="R8a8013b2cc6c473c"/>
           <a:stretch xmlns:a="http://schemas.openxmlformats.org/drawingml/2006/main"/>
         </p:blipFill>
         <p:spPr>
@@ -4430,7 +4430,7 @@
             <a:r>
               <a:rPr sz="1500" b="1">
                 <a:solidFill>
-                  <a:srgbClr val="15803D"/>
+                  <a:srgbClr val="000000"/>
                 </a:solidFill>
               </a:rPr>
               <a:t>① 신뢰도가 높으면 즉시 채택</a:t>
@@ -4481,7 +4481,7 @@
             <a:r>
               <a:rPr sz="1500" b="1">
                 <a:solidFill>
-                  <a:srgbClr val="7C3AED"/>
+                  <a:srgbClr val="000000"/>
                 </a:solidFill>
               </a:rPr>
               <a:t>② 경계 영역만 Answer-only</a:t>
@@ -4532,7 +4532,7 @@
             <a:r>
               <a:rPr sz="1500" b="1">
                 <a:solidFill>
-                  <a:srgbClr val="B45309"/>
+                  <a:srgbClr val="000000"/>
                 </a:solidFill>
               </a:rPr>
               <a:t>③ 불일치·저신뢰만 Upper</a:t>
@@ -4583,7 +4583,7 @@
             <a:r>
               <a:rPr sz="1275" b="0">
                 <a:solidFill>
-                  <a:srgbClr val="5B677A"/>
+                  <a:srgbClr val="000000"/>
                 </a:solidFill>
               </a:rPr>
               <a:t>C3 기준선은 ②에서 전체 풀이를 다시 생성한다</a:t>
@@ -4634,7 +4634,7 @@
             <a:r>
               <a:rPr sz="825" b="0">
                 <a:solidFill>
-                  <a:srgbClr val="8490A3"/>
+                  <a:srgbClr val="000000"/>
                 </a:solidFill>
               </a:rPr>
               <a:t>Capability-aware Adaptive SLM-LLM Routing</a:t>
@@ -4685,7 +4685,7 @@
             <a:r>
               <a:rPr sz="825" b="0">
                 <a:solidFill>
-                  <a:srgbClr val="8490A3"/>
+                  <a:srgbClr val="000000"/>
                 </a:solidFill>
               </a:rPr>
               <a:t>03</a:t>
@@ -4765,7 +4765,7 @@
             <a:r>
               <a:rPr sz="975" b="1">
                 <a:solidFill>
-                  <a:srgbClr val="7C3AED"/>
+                  <a:srgbClr val="000000"/>
                 </a:solidFill>
               </a:rPr>
               <a:t>KSC PILOT</a:t>
@@ -4816,7 +4816,7 @@
             <a:r>
               <a:rPr sz="2700" b="1">
                 <a:solidFill>
-                  <a:srgbClr val="0F172A"/>
+                  <a:srgbClr val="000000"/>
                 </a:solidFill>
               </a:rPr>
               <a:t>전체 재풀이를 ‘답 한 줄’로 바꾸자 검증 시간이 94% 줄었다</a:t>
@@ -4864,7 +4864,7 @@
           <p:nvPr/>
         </p:nvPicPr>
         <p:blipFill>
-          <a:blip xmlns:r="http://schemas.openxmlformats.org/officeDocument/2006/relationships" xmlns:a="http://schemas.openxmlformats.org/drawingml/2006/main" r:embed="R3f985fb924b644c7"/>
+          <a:blip xmlns:r="http://schemas.openxmlformats.org/officeDocument/2006/relationships" xmlns:a="http://schemas.openxmlformats.org/drawingml/2006/main" r:embed="R4e5a4488e9324fd2"/>
           <a:stretch xmlns:a="http://schemas.openxmlformats.org/drawingml/2006/main"/>
         </p:blipFill>
         <p:spPr>
@@ -4920,7 +4920,7 @@
             <a:r>
               <a:rPr sz="1350" b="0">
                 <a:solidFill>
-                  <a:srgbClr val="5B677A"/>
+                  <a:srgbClr val="000000"/>
                 </a:solidFill>
               </a:rPr>
               <a:t>동일 RTX 3090 · 동일 128문항 · batch 16 · 조건별 2회 ABBA</a:t>
@@ -4971,7 +4971,7 @@
             <a:r>
               <a:rPr sz="2025" b="1">
                 <a:solidFill>
-                  <a:srgbClr val="2563EB"/>
+                  <a:srgbClr val="000000"/>
                 </a:solidFill>
               </a:rPr>
               <a:t>처리량 2.03 → 34.32 items/s</a:t>
@@ -5022,7 +5022,7 @@
             <a:r>
               <a:rPr sz="825" b="0">
                 <a:solidFill>
-                  <a:srgbClr val="8490A3"/>
+                  <a:srgbClr val="000000"/>
                 </a:solidFill>
               </a:rPr>
               <a:t>Capability-aware Adaptive SLM-LLM Routing</a:t>
@@ -5073,7 +5073,7 @@
             <a:r>
               <a:rPr sz="825" b="0">
                 <a:solidFill>
-                  <a:srgbClr val="8490A3"/>
+                  <a:srgbClr val="000000"/>
                 </a:solidFill>
               </a:rPr>
               <a:t>04</a:t>
@@ -5153,7 +5153,7 @@
             <a:r>
               <a:rPr sz="975" b="1">
                 <a:solidFill>
-                  <a:srgbClr val="7C3AED"/>
+                  <a:srgbClr val="000000"/>
                 </a:solidFill>
               </a:rPr>
               <a:t>KSC PILOT</a:t>
@@ -5204,7 +5204,7 @@
             <a:r>
               <a:rPr sz="2700" b="1">
                 <a:solidFill>
-                  <a:srgbClr val="0F172A"/>
+                  <a:srgbClr val="000000"/>
                 </a:solidFill>
               </a:rPr>
               <a:t>빠른 검증은 전체 시스템 비용도 19~22% 낮췄다</a:t>
@@ -5286,7 +5286,7 @@
             <a:r>
               <a:rPr sz="3900" b="1">
                 <a:solidFill>
-                  <a:srgbClr val="15803D"/>
+                  <a:srgbClr val="000000"/>
                 </a:solidFill>
               </a:rPr>
               <a:t>99.10%</a:t>
@@ -5337,7 +5337,7 @@
             <a:r>
               <a:rPr sz="1425" b="0">
                 <a:solidFill>
-                  <a:srgbClr val="5B677A"/>
+                  <a:srgbClr val="000000"/>
                 </a:solidFill>
               </a:rPr>
               <a:t>인증 분할: Upper 대비 품질 유지</a:t>
@@ -5388,7 +5388,7 @@
             <a:r>
               <a:rPr sz="3900" b="1">
                 <a:solidFill>
-                  <a:srgbClr val="7C3AED"/>
+                  <a:srgbClr val="000000"/>
                 </a:solidFill>
               </a:rPr>
               <a:t>−22.29%</a:t>
@@ -5439,7 +5439,7 @@
             <a:r>
               <a:rPr sz="1425" b="0">
                 <a:solidFill>
-                  <a:srgbClr val="5B677A"/>
+                  <a:srgbClr val="000000"/>
                 </a:solidFill>
               </a:rPr>
               <a:t>인증 분할: 정규화 비용</a:t>
@@ -5490,7 +5490,7 @@
             <a:r>
               <a:rPr sz="3900" b="1">
                 <a:solidFill>
-                  <a:srgbClr val="2563EB"/>
+                  <a:srgbClr val="000000"/>
                 </a:solidFill>
               </a:rPr>
               <a:t>97.35%</a:t>
@@ -5541,7 +5541,7 @@
             <a:r>
               <a:rPr sz="1425" b="0">
                 <a:solidFill>
-                  <a:srgbClr val="5B677A"/>
+                  <a:srgbClr val="000000"/>
                 </a:solidFill>
               </a:rPr>
               <a:t>공식 테스트: Upper 대비 품질 유지</a:t>
@@ -5623,7 +5623,7 @@
             <a:r>
               <a:rPr sz="1275" b="1">
                 <a:solidFill>
-                  <a:srgbClr val="5B677A"/>
+                  <a:srgbClr val="000000"/>
                 </a:solidFill>
               </a:rPr>
               <a:t>평가</a:t>
@@ -5674,7 +5674,7 @@
             <a:r>
               <a:rPr sz="1275" b="1">
                 <a:solidFill>
-                  <a:srgbClr val="5B677A"/>
+                  <a:srgbClr val="000000"/>
                 </a:solidFill>
               </a:rPr>
               <a:t>방법</a:t>
@@ -5725,7 +5725,7 @@
             <a:r>
               <a:rPr sz="1275" b="1">
                 <a:solidFill>
-                  <a:srgbClr val="5B677A"/>
+                  <a:srgbClr val="000000"/>
                 </a:solidFill>
               </a:rPr>
               <a:t>정확도</a:t>
@@ -5776,7 +5776,7 @@
             <a:r>
               <a:rPr sz="1275" b="1">
                 <a:solidFill>
-                  <a:srgbClr val="5B677A"/>
+                  <a:srgbClr val="000000"/>
                 </a:solidFill>
               </a:rPr>
               <a:t>위험률</a:t>
@@ -5827,7 +5827,7 @@
             <a:r>
               <a:rPr sz="1275" b="1">
                 <a:solidFill>
-                  <a:srgbClr val="5B677A"/>
+                  <a:srgbClr val="000000"/>
                 </a:solidFill>
               </a:rPr>
               <a:t>비용</a:t>
@@ -5878,7 +5878,7 @@
             <a:r>
               <a:rPr sz="1275" b="1">
                 <a:solidFill>
-                  <a:srgbClr val="5B677A"/>
+                  <a:srgbClr val="000000"/>
                 </a:solidFill>
               </a:rPr>
               <a:t>절감</a:t>
@@ -5960,7 +5960,7 @@
             <a:r>
               <a:rPr sz="1350" b="0">
                 <a:solidFill>
-                  <a:srgbClr val="0F172A"/>
+                  <a:srgbClr val="000000"/>
                 </a:solidFill>
               </a:rPr>
               <a:t>인증 250</a:t>
@@ -6011,7 +6011,7 @@
             <a:r>
               <a:rPr sz="1350" b="0">
                 <a:solidFill>
-                  <a:srgbClr val="0F172A"/>
+                  <a:srgbClr val="000000"/>
                 </a:solidFill>
               </a:rPr>
               <a:t>Answer-only</a:t>
@@ -6062,7 +6062,7 @@
             <a:r>
               <a:rPr sz="1350" b="0">
                 <a:solidFill>
-                  <a:srgbClr val="0F172A"/>
+                  <a:srgbClr val="000000"/>
                 </a:solidFill>
               </a:rPr>
               <a:t>88.00%</a:t>
@@ -6113,7 +6113,7 @@
             <a:r>
               <a:rPr sz="1350" b="0">
                 <a:solidFill>
-                  <a:srgbClr val="0F172A"/>
+                  <a:srgbClr val="000000"/>
                 </a:solidFill>
               </a:rPr>
               <a:t>2.80%</a:t>
@@ -6164,7 +6164,7 @@
             <a:r>
               <a:rPr sz="1350" b="1">
                 <a:solidFill>
-                  <a:srgbClr val="7C3AED"/>
+                  <a:srgbClr val="000000"/>
                 </a:solidFill>
               </a:rPr>
               <a:t>0.777</a:t>
@@ -6215,7 +6215,7 @@
             <a:r>
               <a:rPr sz="1350" b="1">
                 <a:solidFill>
-                  <a:srgbClr val="7C3AED"/>
+                  <a:srgbClr val="000000"/>
                 </a:solidFill>
               </a:rPr>
               <a:t>22.29%</a:t>
@@ -6297,7 +6297,7 @@
             <a:r>
               <a:rPr sz="1350" b="0">
                 <a:solidFill>
-                  <a:srgbClr val="0F172A"/>
+                  <a:srgbClr val="000000"/>
                 </a:solidFill>
               </a:rPr>
               <a:t>테스트 300</a:t>
@@ -6348,7 +6348,7 @@
             <a:r>
               <a:rPr sz="1350" b="0">
                 <a:solidFill>
-                  <a:srgbClr val="0F172A"/>
+                  <a:srgbClr val="000000"/>
                 </a:solidFill>
               </a:rPr>
               <a:t>Answer-only</a:t>
@@ -6399,7 +6399,7 @@
             <a:r>
               <a:rPr sz="1350" b="0">
                 <a:solidFill>
-                  <a:srgbClr val="0F172A"/>
+                  <a:srgbClr val="000000"/>
                 </a:solidFill>
               </a:rPr>
               <a:t>85.67%</a:t>
@@ -6450,7 +6450,7 @@
             <a:r>
               <a:rPr sz="1350" b="0">
                 <a:solidFill>
-                  <a:srgbClr val="0F172A"/>
+                  <a:srgbClr val="000000"/>
                 </a:solidFill>
               </a:rPr>
               <a:t>3.00%</a:t>
@@ -6501,7 +6501,7 @@
             <a:r>
               <a:rPr sz="1350" b="1">
                 <a:solidFill>
-                  <a:srgbClr val="7C3AED"/>
+                  <a:srgbClr val="000000"/>
                 </a:solidFill>
               </a:rPr>
               <a:t>0.806</a:t>
@@ -6552,7 +6552,7 @@
             <a:r>
               <a:rPr sz="1350" b="1">
                 <a:solidFill>
-                  <a:srgbClr val="7C3AED"/>
+                  <a:srgbClr val="000000"/>
                 </a:solidFill>
               </a:rPr>
               <a:t>19.42%</a:t>
@@ -6603,7 +6603,7 @@
             <a:r>
               <a:rPr sz="1350" b="0">
                 <a:solidFill>
-                  <a:srgbClr val="0F172A"/>
+                  <a:srgbClr val="000000"/>
                 </a:solidFill>
               </a:rPr>
               <a:t>인증 250</a:t>
@@ -6654,7 +6654,7 @@
             <a:r>
               <a:rPr sz="1350" b="0">
                 <a:solidFill>
-                  <a:srgbClr val="0F172A"/>
+                  <a:srgbClr val="000000"/>
                 </a:solidFill>
               </a:rPr>
               <a:t>C3</a:t>
@@ -6705,7 +6705,7 @@
             <a:r>
               <a:rPr sz="1350" b="0">
                 <a:solidFill>
-                  <a:srgbClr val="0F172A"/>
+                  <a:srgbClr val="000000"/>
                 </a:solidFill>
               </a:rPr>
               <a:t>88.80%</a:t>
@@ -6756,7 +6756,7 @@
             <a:r>
               <a:rPr sz="1350" b="0">
                 <a:solidFill>
-                  <a:srgbClr val="0F172A"/>
+                  <a:srgbClr val="000000"/>
                 </a:solidFill>
               </a:rPr>
               <a:t>2.00%</a:t>
@@ -6807,7 +6807,7 @@
             <a:r>
               <a:rPr sz="1350" b="0">
                 <a:solidFill>
-                  <a:srgbClr val="0F172A"/>
+                  <a:srgbClr val="000000"/>
                 </a:solidFill>
               </a:rPr>
               <a:t>1.008</a:t>
@@ -6858,7 +6858,7 @@
             <a:r>
               <a:rPr sz="1350" b="0">
                 <a:solidFill>
-                  <a:srgbClr val="0F172A"/>
+                  <a:srgbClr val="000000"/>
                 </a:solidFill>
               </a:rPr>
               <a:t>−0.77%</a:t>
@@ -6909,7 +6909,7 @@
             <a:r>
               <a:rPr sz="1125" b="0">
                 <a:solidFill>
-                  <a:srgbClr val="5B677A"/>
+                  <a:srgbClr val="000000"/>
                 </a:solidFill>
               </a:rPr>
               <a:t>Always-Upper 비용 = 1.000</a:t>
@@ -6960,7 +6960,7 @@
             <a:r>
               <a:rPr sz="825" b="0">
                 <a:solidFill>
-                  <a:srgbClr val="8490A3"/>
+                  <a:srgbClr val="000000"/>
                 </a:solidFill>
               </a:rPr>
               <a:t>Capability-aware Adaptive SLM-LLM Routing</a:t>
@@ -7011,7 +7011,7 @@
             <a:r>
               <a:rPr sz="825" b="0">
                 <a:solidFill>
-                  <a:srgbClr val="8490A3"/>
+                  <a:srgbClr val="000000"/>
                 </a:solidFill>
               </a:rPr>
               <a:t>05</a:t>
@@ -7091,7 +7091,7 @@
             <a:r>
               <a:rPr sz="975" b="1">
                 <a:solidFill>
-                  <a:srgbClr val="7C3AED"/>
+                  <a:srgbClr val="000000"/>
                 </a:solidFill>
               </a:rPr>
               <a:t>KSC PILOT</a:t>
@@ -7142,7 +7142,7 @@
             <a:r>
               <a:rPr sz="2700" b="1">
                 <a:solidFill>
-                  <a:srgbClr val="0F172A"/>
+                  <a:srgbClr val="000000"/>
                 </a:solidFill>
               </a:rPr>
               <a:t>결과는 유망하지만, 5% 안전 보장은 아직 통과하지 못했다</a:t>
@@ -7224,7 +7224,7 @@
             <a:r>
               <a:rPr sz="1500" b="1">
                 <a:solidFill>
-                  <a:srgbClr val="5B677A"/>
+                  <a:srgbClr val="000000"/>
                 </a:solidFill>
               </a:rPr>
               <a:t>관측 위험률</a:t>
@@ -7275,7 +7275,7 @@
             <a:r>
               <a:rPr sz="4350" b="1">
                 <a:solidFill>
-                  <a:srgbClr val="15803D"/>
+                  <a:srgbClr val="000000"/>
                 </a:solidFill>
               </a:rPr>
               <a:t>2.80%</a:t>
@@ -7326,7 +7326,7 @@
             <a:r>
               <a:rPr sz="1350" b="0">
                 <a:solidFill>
-                  <a:srgbClr val="5B677A"/>
+                  <a:srgbClr val="000000"/>
                 </a:solidFill>
               </a:rPr>
               <a:t>7 / 250</a:t>
@@ -7377,7 +7377,7 @@
             <a:r>
               <a:rPr sz="1500" b="1">
                 <a:solidFill>
-                  <a:srgbClr val="5B677A"/>
+                  <a:srgbClr val="000000"/>
                 </a:solidFill>
               </a:rPr>
               <a:t>95% 단측 상한</a:t>
@@ -7428,7 +7428,7 @@
             <a:r>
               <a:rPr sz="4350" b="1">
                 <a:solidFill>
-                  <a:srgbClr val="B45309"/>
+                  <a:srgbClr val="000000"/>
                 </a:solidFill>
               </a:rPr>
               <a:t>5.195%</a:t>
@@ -7479,7 +7479,7 @@
             <a:r>
               <a:rPr sz="1350" b="0">
                 <a:solidFill>
-                  <a:srgbClr val="B91C1C"/>
+                  <a:srgbClr val="000000"/>
                 </a:solidFill>
               </a:rPr>
               <a:t>목표 5.0%보다 +0.195%p</a:t>
@@ -7530,7 +7530,7 @@
             <a:r>
               <a:rPr sz="1500" b="1">
                 <a:solidFill>
-                  <a:srgbClr val="5B677A"/>
+                  <a:srgbClr val="000000"/>
                 </a:solidFill>
               </a:rPr>
               <a:t>정확도 차이</a:t>
@@ -7581,7 +7581,7 @@
             <a:r>
               <a:rPr sz="2550" b="1">
                 <a:solidFill>
-                  <a:srgbClr val="2563EB"/>
+                  <a:srgbClr val="000000"/>
                 </a:solidFill>
               </a:rPr>
               <a:t>유의하지 않음</a:t>
@@ -7632,7 +7632,7 @@
             <a:r>
               <a:rPr sz="1350" b="0">
                 <a:solidFill>
-                  <a:srgbClr val="5B677A"/>
+                  <a:srgbClr val="000000"/>
                 </a:solidFill>
               </a:rPr>
               <a:t>McNemar p=.625 / .146</a:t>
@@ -7714,7 +7714,7 @@
             <a:r>
               <a:rPr sz="1650" b="1">
                 <a:solidFill>
-                  <a:srgbClr val="15803D"/>
+                  <a:srgbClr val="000000"/>
                 </a:solidFill>
               </a:rPr>
               <a:t>해석해야 하는 것</a:t>
@@ -7798,7 +7798,7 @@
             <a:r>
               <a:rPr sz="1575" b="0">
                 <a:solidFill>
-                  <a:srgbClr val="0F172A"/>
+                  <a:srgbClr val="000000"/>
                 </a:solidFill>
               </a:rPr>
               <a:t>관측된 성능-비용 Pareto frontier 개선</a:t>
@@ -7882,7 +7882,7 @@
             <a:r>
               <a:rPr sz="1575" b="0">
                 <a:solidFill>
-                  <a:srgbClr val="0F172A"/>
+                  <a:srgbClr val="000000"/>
                 </a:solidFill>
               </a:rPr>
               <a:t>비용 감소 신뢰구간은 0을 포함하지 않음</a:t>
@@ -7933,7 +7933,7 @@
             <a:r>
               <a:rPr sz="1650" b="1">
                 <a:solidFill>
-                  <a:srgbClr val="B91C1C"/>
+                  <a:srgbClr val="000000"/>
                 </a:solidFill>
               </a:rPr>
               <a:t>말하면 안 되는 것</a:t>
@@ -8017,7 +8017,7 @@
             <a:r>
               <a:rPr sz="1575" b="0">
                 <a:solidFill>
-                  <a:srgbClr val="0F172A"/>
+                  <a:srgbClr val="000000"/>
                 </a:solidFill>
               </a:rPr>
               <a:t>‘정확도가 동일하다’ 또는 ‘비열등성을 증명했다’</a:t>
@@ -8101,7 +8101,7 @@
             <a:r>
               <a:rPr sz="1575" b="0">
                 <a:solidFill>
-                  <a:srgbClr val="0F172A"/>
+                  <a:srgbClr val="000000"/>
                 </a:solidFill>
               </a:rPr>
               <a:t>‘위험률 5% 이하를 보장한다’</a:t>
@@ -8152,7 +8152,7 @@
             <a:r>
               <a:rPr sz="825" b="0">
                 <a:solidFill>
-                  <a:srgbClr val="8490A3"/>
+                  <a:srgbClr val="000000"/>
                 </a:solidFill>
               </a:rPr>
               <a:t>Capability-aware Adaptive SLM-LLM Routing</a:t>
@@ -8203,7 +8203,7 @@
             <a:r>
               <a:rPr sz="825" b="0">
                 <a:solidFill>
-                  <a:srgbClr val="8490A3"/>
+                  <a:srgbClr val="000000"/>
                 </a:solidFill>
               </a:rPr>
               <a:t>06</a:t>
@@ -8283,7 +8283,7 @@
             <a:r>
               <a:rPr sz="975" b="1">
                 <a:solidFill>
-                  <a:srgbClr val="7C3AED"/>
+                  <a:srgbClr val="000000"/>
                 </a:solidFill>
               </a:rPr>
               <a:t>KSC PILOT</a:t>
@@ -8334,7 +8334,7 @@
             <a:r>
               <a:rPr sz="2700" b="1">
                 <a:solidFill>
-                  <a:srgbClr val="0F172A"/>
+                  <a:srgbClr val="000000"/>
                 </a:solidFill>
               </a:rPr>
               <a:t>임계값을 높일수록 정확도는 오르지만 비용도 함께 증가한다</a:t>
@@ -8382,7 +8382,7 @@
           <p:nvPr/>
         </p:nvPicPr>
         <p:blipFill>
-          <a:blip xmlns:r="http://schemas.openxmlformats.org/officeDocument/2006/relationships" xmlns:a="http://schemas.openxmlformats.org/drawingml/2006/main" r:embed="R74a325f5e4024e9f"/>
+          <a:blip xmlns:r="http://schemas.openxmlformats.org/officeDocument/2006/relationships" xmlns:a="http://schemas.openxmlformats.org/drawingml/2006/main" r:embed="R5c2e126975404fa2"/>
           <a:stretch xmlns:a="http://schemas.openxmlformats.org/drawingml/2006/main"/>
         </p:blipFill>
         <p:spPr>
@@ -8438,7 +8438,7 @@
             <a:r>
               <a:rPr sz="1500" b="1">
                 <a:solidFill>
-                  <a:srgbClr val="5B677A"/>
+                  <a:srgbClr val="000000"/>
                 </a:solidFill>
               </a:rPr>
               <a:t>사전에 고정한 정책</a:t>
@@ -8489,25 +8489,25 @@
             <a:r>
               <a:rPr sz="3000" b="1">
                 <a:solidFill>
+                  <a:srgbClr val="000000"/>
+                </a:solidFill>
+              </a:rPr>
+              <a:t>τₗ = 0.12</a:t>
+            </a:r>
+          </a:p>
+          <a:p xmlns:a="http://schemas.openxmlformats.org/drawingml/2006/main">
+            <a:pPr algn="l">
+              <a:buNone/>
+              <a:defRPr sz="3000" b="1">
+                <a:solidFill>
                   <a:srgbClr val="7C3AED"/>
                 </a:solidFill>
-              </a:rPr>
-              <a:t>τₗ = 0.12</a:t>
-            </a:r>
-          </a:p>
-          <a:p xmlns:a="http://schemas.openxmlformats.org/drawingml/2006/main">
-            <a:pPr algn="l">
-              <a:buNone/>
-              <a:defRPr sz="3000" b="1">
-                <a:solidFill>
-                  <a:srgbClr val="7C3AED"/>
-                </a:solidFill>
               </a:defRPr>
             </a:pPr>
             <a:r>
               <a:rPr sz="3000" b="1">
                 <a:solidFill>
-                  <a:srgbClr val="7C3AED"/>
+                  <a:srgbClr val="000000"/>
                 </a:solidFill>
               </a:rPr>
               <a:t>τₕ = 0.80</a:t>
@@ -8591,7 +8591,7 @@
             <a:r>
               <a:rPr sz="1500" b="0">
                 <a:solidFill>
-                  <a:srgbClr val="0F172A"/>
+                  <a:srgbClr val="000000"/>
                 </a:solidFill>
               </a:rPr>
               <a:t>정책 선택 250문항에서만 선택</a:t>
@@ -8675,7 +8675,7 @@
             <a:r>
               <a:rPr sz="1500" b="0">
                 <a:solidFill>
-                  <a:srgbClr val="0F172A"/>
+                  <a:srgbClr val="000000"/>
                 </a:solidFill>
               </a:rPr>
               <a:t>독립 인증 250문항은 이후 한 번 평가</a:t>
@@ -8759,7 +8759,7 @@
             <a:r>
               <a:rPr sz="1500" b="0">
                 <a:solidFill>
-                  <a:srgbClr val="0F172A"/>
+                  <a:srgbClr val="000000"/>
                 </a:solidFill>
               </a:rPr>
               <a:t>0.12/0.82는 사후 참고점</a:t>
@@ -8810,7 +8810,7 @@
             <a:r>
               <a:rPr sz="825" b="0">
                 <a:solidFill>
-                  <a:srgbClr val="8490A3"/>
+                  <a:srgbClr val="000000"/>
                 </a:solidFill>
               </a:rPr>
               <a:t>Capability-aware Adaptive SLM-LLM Routing</a:t>
@@ -8861,7 +8861,7 @@
             <a:r>
               <a:rPr sz="825" b="0">
                 <a:solidFill>
-                  <a:srgbClr val="8490A3"/>
+                  <a:srgbClr val="000000"/>
                 </a:solidFill>
               </a:rPr>
               <a:t>07</a:t>
@@ -8941,7 +8941,7 @@
             <a:r>
               <a:rPr sz="975" b="1">
                 <a:solidFill>
-                  <a:srgbClr val="7C3AED"/>
+                  <a:srgbClr val="000000"/>
                 </a:solidFill>
               </a:rPr>
               <a:t>KSC PILOT</a:t>
@@ -8992,7 +8992,7 @@
             <a:r>
               <a:rPr sz="2700" b="1">
                 <a:solidFill>
-                  <a:srgbClr val="0F172A"/>
+                  <a:srgbClr val="000000"/>
                 </a:solidFill>
               </a:rPr>
               <a:t>차별점은 ‘질문’이 아니라 ‘방금 생성된 답’을 보고 결정하는 것이다</a:t>
@@ -9074,7 +9074,7 @@
             <a:r>
               <a:rPr sz="1425" b="1">
                 <a:solidFill>
-                  <a:srgbClr val="0F172A"/>
+                  <a:srgbClr val="000000"/>
                 </a:solidFill>
               </a:rPr>
               <a:t>비교</a:t>
@@ -9125,7 +9125,7 @@
             <a:r>
               <a:rPr sz="1425" b="1">
                 <a:solidFill>
-                  <a:srgbClr val="0F172A"/>
+                  <a:srgbClr val="000000"/>
                 </a:solidFill>
               </a:rPr>
               <a:t>Query-only routing</a:t>
@@ -9176,7 +9176,7 @@
             <a:r>
               <a:rPr sz="1425" b="1">
                 <a:solidFill>
-                  <a:srgbClr val="0F172A"/>
+                  <a:srgbClr val="000000"/>
                 </a:solidFill>
               </a:rPr>
               <a:t>전체 풀이 cascade</a:t>
@@ -9258,7 +9258,7 @@
             <a:r>
               <a:rPr sz="1425" b="1">
                 <a:solidFill>
-                  <a:srgbClr val="7C3AED"/>
+                  <a:srgbClr val="000000"/>
                 </a:solidFill>
               </a:rPr>
               <a:t>본 연구</a:t>
@@ -9340,7 +9340,7 @@
             <a:r>
               <a:rPr sz="1275" b="1">
                 <a:solidFill>
-                  <a:srgbClr val="5B677A"/>
+                  <a:srgbClr val="000000"/>
                 </a:solidFill>
               </a:rPr>
               <a:t>판단 신호</a:t>
@@ -9391,7 +9391,7 @@
             <a:r>
               <a:rPr sz="1350" b="0">
                 <a:solidFill>
-                  <a:srgbClr val="0F172A"/>
+                  <a:srgbClr val="000000"/>
                 </a:solidFill>
               </a:rPr>
               <a:t>질문 임베딩</a:t>
@@ -9442,7 +9442,7 @@
             <a:r>
               <a:rPr sz="1350" b="0">
                 <a:solidFill>
-                  <a:srgbClr val="0F172A"/>
+                  <a:srgbClr val="000000"/>
                 </a:solidFill>
               </a:rPr>
               <a:t>첫 답 + 전체 재풀이</a:t>
@@ -9493,7 +9493,7 @@
             <a:r>
               <a:rPr sz="1350" b="1">
                 <a:solidFill>
-                  <a:srgbClr val="7C3AED"/>
+                  <a:srgbClr val="000000"/>
                 </a:solidFill>
               </a:rPr>
               <a:t>첫 답 신뢰도 + 정답 한 줄</a:t>
@@ -9575,7 +9575,7 @@
             <a:r>
               <a:rPr sz="1275" b="1">
                 <a:solidFill>
-                  <a:srgbClr val="5B677A"/>
+                  <a:srgbClr val="000000"/>
                 </a:solidFill>
               </a:rPr>
               <a:t>두 번째 호출</a:t>
@@ -9626,7 +9626,7 @@
             <a:r>
               <a:rPr sz="1350" b="0">
                 <a:solidFill>
-                  <a:srgbClr val="0F172A"/>
+                  <a:srgbClr val="000000"/>
                 </a:solidFill>
               </a:rPr>
               <a:t>없음</a:t>
@@ -9677,7 +9677,7 @@
             <a:r>
               <a:rPr sz="1350" b="0">
                 <a:solidFill>
-                  <a:srgbClr val="0F172A"/>
+                  <a:srgbClr val="000000"/>
                 </a:solidFill>
               </a:rPr>
               <a:t>평균 124.55토큰</a:t>
@@ -9728,7 +9728,7 @@
             <a:r>
               <a:rPr sz="1350" b="1">
                 <a:solidFill>
-                  <a:srgbClr val="7C3AED"/>
+                  <a:srgbClr val="000000"/>
                 </a:solidFill>
               </a:rPr>
               <a:t>평균 5.40토큰*</a:t>
@@ -9810,7 +9810,7 @@
             <a:r>
               <a:rPr sz="1275" b="1">
                 <a:solidFill>
-                  <a:srgbClr val="5B677A"/>
+                  <a:srgbClr val="000000"/>
                 </a:solidFill>
               </a:rPr>
               <a:t>실측 비용</a:t>
@@ -9861,7 +9861,7 @@
             <a:r>
               <a:rPr sz="1350" b="0">
                 <a:solidFill>
-                  <a:srgbClr val="0F172A"/>
+                  <a:srgbClr val="000000"/>
                 </a:solidFill>
               </a:rPr>
               <a:t>보통 호출 수 중심</a:t>
@@ -9912,7 +9912,7 @@
             <a:r>
               <a:rPr sz="1350" b="0">
                 <a:solidFill>
-                  <a:srgbClr val="0F172A"/>
+                  <a:srgbClr val="000000"/>
                 </a:solidFill>
               </a:rPr>
               <a:t>검증 오버헤드 큼</a:t>
@@ -9963,7 +9963,7 @@
             <a:r>
               <a:rPr sz="1350" b="1">
                 <a:solidFill>
-                  <a:srgbClr val="7C3AED"/>
+                  <a:srgbClr val="000000"/>
                 </a:solidFill>
               </a:rPr>
               <a:t>1차·검증·Upper를 모두 합산</a:t>
@@ -10045,7 +10045,7 @@
             <a:r>
               <a:rPr sz="1275" b="1">
                 <a:solidFill>
-                  <a:srgbClr val="5B677A"/>
+                  <a:srgbClr val="000000"/>
                 </a:solidFill>
               </a:rPr>
               <a:t>위험 검증</a:t>
@@ -10096,7 +10096,7 @@
             <a:r>
               <a:rPr sz="1350" b="0">
                 <a:solidFill>
-                  <a:srgbClr val="0F172A"/>
+                  <a:srgbClr val="000000"/>
                 </a:solidFill>
               </a:rPr>
               <a:t>일반 테스트</a:t>
@@ -10147,7 +10147,7 @@
             <a:r>
               <a:rPr sz="1350" b="0">
                 <a:solidFill>
-                  <a:srgbClr val="0F172A"/>
+                  <a:srgbClr val="000000"/>
                 </a:solidFill>
               </a:rPr>
               <a:t>일반 테스트</a:t>
@@ -10198,7 +10198,7 @@
             <a:r>
               <a:rPr sz="1350" b="1">
                 <a:solidFill>
-                  <a:srgbClr val="7C3AED"/>
+                  <a:srgbClr val="000000"/>
                 </a:solidFill>
               </a:rPr>
               <a:t>250/250 분리 + 95% 상한</a:t>
@@ -10280,7 +10280,7 @@
             <a:r>
               <a:rPr sz="1275" b="1">
                 <a:solidFill>
-                  <a:srgbClr val="5B677A"/>
+                  <a:srgbClr val="000000"/>
                 </a:solidFill>
               </a:rPr>
               <a:t>업데이트 대응</a:t>
@@ -10331,7 +10331,7 @@
             <a:r>
               <a:rPr sz="1350" b="0">
                 <a:solidFill>
-                  <a:srgbClr val="0F172A"/>
+                  <a:srgbClr val="000000"/>
                 </a:solidFill>
               </a:rPr>
               <a:t>분류기 재학습</a:t>
@@ -10382,7 +10382,7 @@
             <a:r>
               <a:rPr sz="1350" b="0">
                 <a:solidFill>
-                  <a:srgbClr val="0F172A"/>
+                  <a:srgbClr val="000000"/>
                 </a:solidFill>
               </a:rPr>
               <a:t>정책 재학습</a:t>
@@ -10433,7 +10433,7 @@
             <a:r>
               <a:rPr sz="1350" b="1">
                 <a:solidFill>
-                  <a:srgbClr val="7C3AED"/>
+                  <a:srgbClr val="000000"/>
                 </a:solidFill>
               </a:rPr>
               <a:t>임계값 재보정 구조 제안</a:t>
@@ -10484,7 +10484,7 @@
             <a:r>
               <a:rPr sz="1050" b="0">
                 <a:solidFill>
-                  <a:srgbClr val="5B677A"/>
+                  <a:srgbClr val="000000"/>
                 </a:solidFill>
               </a:rPr>
               <a:t>* 지연시간 벤치마크 128문항 기준</a:t>
@@ -10535,7 +10535,7 @@
             <a:r>
               <a:rPr sz="825" b="0">
                 <a:solidFill>
-                  <a:srgbClr val="8490A3"/>
+                  <a:srgbClr val="000000"/>
                 </a:solidFill>
               </a:rPr>
               <a:t>Capability-aware Adaptive SLM-LLM Routing</a:t>
@@ -10586,7 +10586,7 @@
             <a:r>
               <a:rPr sz="825" b="0">
                 <a:solidFill>
-                  <a:srgbClr val="8490A3"/>
+                  <a:srgbClr val="000000"/>
                 </a:solidFill>
               </a:rPr>
               <a:t>08</a:t>
@@ -10666,7 +10666,7 @@
             <a:r>
               <a:rPr sz="975" b="1">
                 <a:solidFill>
-                  <a:srgbClr val="7C3AED"/>
+                  <a:srgbClr val="000000"/>
                 </a:solidFill>
               </a:rPr>
               <a:t>KSC PILOT</a:t>
@@ -10717,7 +10717,7 @@
             <a:r>
               <a:rPr sz="2700" b="1">
                 <a:solidFill>
-                  <a:srgbClr val="0F172A"/>
+                  <a:srgbClr val="000000"/>
                 </a:solidFill>
               </a:rPr>
               <a:t>검증된 기여와 앞으로 검증할 구조를 분리한다</a:t>
@@ -10799,7 +10799,7 @@
             <a:r>
               <a:rPr sz="1875" b="1">
                 <a:solidFill>
-                  <a:srgbClr val="15803D"/>
+                  <a:srgbClr val="000000"/>
                 </a:solidFill>
               </a:rPr>
               <a:t>이번 파일럿에서 검증</a:t>
@@ -10883,7 +10883,7 @@
             <a:r>
               <a:rPr sz="1575" b="0">
                 <a:solidFill>
-                  <a:srgbClr val="0F172A"/>
+                  <a:srgbClr val="000000"/>
                 </a:solidFill>
               </a:rPr>
               <a:t>Answer-only의 GPU 지연시간 94.09% 감소</a:t>
@@ -10967,7 +10967,7 @@
             <a:r>
               <a:rPr sz="1575" b="0">
                 <a:solidFill>
-                  <a:srgbClr val="0F172A"/>
+                  <a:srgbClr val="000000"/>
                 </a:solidFill>
               </a:rPr>
               <a:t>독립 분할에서 품질·비용 효과 재현</a:t>
@@ -11051,7 +11051,7 @@
             <a:r>
               <a:rPr sz="1575" b="0">
                 <a:solidFill>
-                  <a:srgbClr val="0F172A"/>
+                  <a:srgbClr val="000000"/>
                 </a:solidFill>
               </a:rPr>
               <a:t>Paired bootstrap·McNemar·정확 위험 상한</a:t>
@@ -11135,7 +11135,7 @@
             <a:r>
               <a:rPr sz="1575" b="0">
                 <a:solidFill>
-                  <a:srgbClr val="0F172A"/>
+                  <a:srgbClr val="000000"/>
                 </a:solidFill>
               </a:rPr>
               <a:t>안전 기준 실패까지 포함한 정직한 보고</a:t>
@@ -11217,7 +11217,7 @@
             <a:r>
               <a:rPr sz="1875" b="1">
                 <a:solidFill>
-                  <a:srgbClr val="7C3AED"/>
+                  <a:srgbClr val="000000"/>
                 </a:solidFill>
               </a:rPr>
               <a:t>운영 확장으로 제안</a:t>
@@ -11301,7 +11301,7 @@
             <a:r>
               <a:rPr sz="1575" b="0">
                 <a:solidFill>
-                  <a:srgbClr val="0F172A"/>
+                  <a:srgbClr val="000000"/>
                 </a:solidFill>
               </a:rPr>
               <a:t>Lower 업데이트 후 신뢰도 drift 측정</a:t>
@@ -11385,7 +11385,7 @@
             <a:r>
               <a:rPr sz="1575" b="0">
                 <a:solidFill>
-                  <a:srgbClr val="0F172A"/>
+                  <a:srgbClr val="000000"/>
                 </a:solidFill>
               </a:rPr>
               <a:t>작은 calibration set으로 임계값 재보정</a:t>
@@ -11469,7 +11469,7 @@
             <a:r>
               <a:rPr sz="1575" b="0">
                 <a:solidFill>
-                  <a:srgbClr val="0F172A"/>
+                  <a:srgbClr val="000000"/>
                 </a:solidFill>
               </a:rPr>
               <a:t>위험 상한 제약 아래 비용 최소화</a:t>
@@ -11520,7 +11520,7 @@
             <a:r>
               <a:rPr sz="1425" b="1">
                 <a:solidFill>
-                  <a:srgbClr val="B91C1C"/>
+                  <a:srgbClr val="000000"/>
                 </a:solidFill>
               </a:rPr>
               <a:t>아직 완전한 MLOps 실증 결과로 주장하지 않는다</a:t>
@@ -11571,7 +11571,7 @@
             <a:r>
               <a:rPr sz="825" b="0">
                 <a:solidFill>
-                  <a:srgbClr val="8490A3"/>
+                  <a:srgbClr val="000000"/>
                 </a:solidFill>
               </a:rPr>
               <a:t>Capability-aware Adaptive SLM-LLM Routing</a:t>
@@ -11622,7 +11622,7 @@
             <a:r>
               <a:rPr sz="825" b="0">
                 <a:solidFill>
-                  <a:srgbClr val="8490A3"/>
+                  <a:srgbClr val="000000"/>
                 </a:solidFill>
               </a:rPr>
               <a:t>09</a:t>

</xml_diff>

<commit_message>
docs: clarify quality retention story
</commit_message>
<xml_diff>
--- a/paper/presentation/KSC_PILOT_presentation.pptx
+++ b/paper/presentation/KSC_PILOT_presentation.pptx
@@ -2,25 +2,25 @@
 <file path=ppt/presentation.xml><?xml version="1.0" encoding="utf-8"?>
 <p:presentation xmlns:p="http://schemas.openxmlformats.org/presentationml/2006/main">
   <p:sldMasterIdLst>
-    <p:sldMasterId xmlns:r="http://schemas.openxmlformats.org/officeDocument/2006/relationships" id="2147483648" r:id="R6266a49d1ecf4e6d"/>
+    <p:sldMasterId xmlns:r="http://schemas.openxmlformats.org/officeDocument/2006/relationships" id="2147483648" r:id="R9c33cf958ad549ed"/>
   </p:sldMasterIdLst>
   <p:notesMasterIdLst>
-    <p:notesMasterId xmlns:r="http://schemas.openxmlformats.org/officeDocument/2006/relationships" r:id="R8d4bd45d65434590"/>
+    <p:notesMasterId xmlns:r="http://schemas.openxmlformats.org/officeDocument/2006/relationships" r:id="R27d2abef6db44d9d"/>
   </p:notesMasterIdLst>
   <p:sldIdLst>
-    <p:sldId xmlns:r="http://schemas.openxmlformats.org/officeDocument/2006/relationships" id="256" r:id="R8e7856d2d3434655"/>
-    <p:sldId xmlns:r="http://schemas.openxmlformats.org/officeDocument/2006/relationships" id="257" r:id="Rbe6583045f264e75"/>
-    <p:sldId xmlns:r="http://schemas.openxmlformats.org/officeDocument/2006/relationships" id="258" r:id="R5af31ac3d5b54839"/>
-    <p:sldId xmlns:r="http://schemas.openxmlformats.org/officeDocument/2006/relationships" id="259" r:id="R9ba4dceeb6d34779"/>
-    <p:sldId xmlns:r="http://schemas.openxmlformats.org/officeDocument/2006/relationships" id="260" r:id="R0da06d7b53684429"/>
-    <p:sldId xmlns:r="http://schemas.openxmlformats.org/officeDocument/2006/relationships" id="261" r:id="R99af9bcc4c994f33"/>
-    <p:sldId xmlns:r="http://schemas.openxmlformats.org/officeDocument/2006/relationships" id="262" r:id="R78781d43d594478f"/>
-    <p:sldId xmlns:r="http://schemas.openxmlformats.org/officeDocument/2006/relationships" id="263" r:id="R04634f33fd064a52"/>
-    <p:sldId xmlns:r="http://schemas.openxmlformats.org/officeDocument/2006/relationships" id="264" r:id="Ra8e2c4f303244348"/>
-    <p:sldId xmlns:r="http://schemas.openxmlformats.org/officeDocument/2006/relationships" id="265" r:id="R376729c68d5e4f17"/>
-    <p:sldId xmlns:r="http://schemas.openxmlformats.org/officeDocument/2006/relationships" id="266" r:id="R9db68e0d33274ca2"/>
-    <p:sldId xmlns:r="http://schemas.openxmlformats.org/officeDocument/2006/relationships" id="267" r:id="Rac1a22d1b5684a52"/>
-    <p:sldId xmlns:r="http://schemas.openxmlformats.org/officeDocument/2006/relationships" id="268" r:id="Re2377b3acb604dc3"/>
+    <p:sldId xmlns:r="http://schemas.openxmlformats.org/officeDocument/2006/relationships" id="256" r:id="Rcc5164b3f7ef4f3a"/>
+    <p:sldId xmlns:r="http://schemas.openxmlformats.org/officeDocument/2006/relationships" id="257" r:id="R8846d014bed748e8"/>
+    <p:sldId xmlns:r="http://schemas.openxmlformats.org/officeDocument/2006/relationships" id="258" r:id="R1bfbd8e3ad734385"/>
+    <p:sldId xmlns:r="http://schemas.openxmlformats.org/officeDocument/2006/relationships" id="259" r:id="R87966bcebbe145e8"/>
+    <p:sldId xmlns:r="http://schemas.openxmlformats.org/officeDocument/2006/relationships" id="260" r:id="R81cb9e5d45194c37"/>
+    <p:sldId xmlns:r="http://schemas.openxmlformats.org/officeDocument/2006/relationships" id="261" r:id="R7f9fd3071de248c6"/>
+    <p:sldId xmlns:r="http://schemas.openxmlformats.org/officeDocument/2006/relationships" id="262" r:id="R0ad0e4933c5e4fb3"/>
+    <p:sldId xmlns:r="http://schemas.openxmlformats.org/officeDocument/2006/relationships" id="263" r:id="R04d5741f68074a91"/>
+    <p:sldId xmlns:r="http://schemas.openxmlformats.org/officeDocument/2006/relationships" id="264" r:id="R90c8388131c04629"/>
+    <p:sldId xmlns:r="http://schemas.openxmlformats.org/officeDocument/2006/relationships" id="265" r:id="R7a9d64ff99514b83"/>
+    <p:sldId xmlns:r="http://schemas.openxmlformats.org/officeDocument/2006/relationships" id="266" r:id="Rbe93cc7fc39a410d"/>
+    <p:sldId xmlns:r="http://schemas.openxmlformats.org/officeDocument/2006/relationships" id="267" r:id="R6c404676d2f7448e"/>
+    <p:sldId xmlns:r="http://schemas.openxmlformats.org/officeDocument/2006/relationships" id="268" r:id="Rfbefa1b8dd7f4cd9"/>
   </p:sldIdLst>
   <p:sldSz cx="12192000" cy="6858000"/>
   <p:notesSz cx="6858000" cy="9144000"/>
@@ -819,7 +819,7 @@
           <a:lstStyle xmlns:a="http://schemas.openxmlformats.org/drawingml/2006/main"/>
           <a:p xmlns:a="http://schemas.openxmlformats.org/drawingml/2006/main">
             <a:r>
-              <a:t>마지막 메시지는 성능-비용 frontier 개선이다. 안전 보장이나 모든 도메인 일반화를 주장하지 않는다.</a:t>
+              <a:t>마지막 메시지는 Upper보다 정답률을 높였다는 것이 아니다. Lower를 활용하면서도 독립 평가에서 Upper 품질의 97.35~99.10%를 유지했고, 전체 비용은 19.42~22.29% 절감했으며, Answer-only 검증은 29.15ms였다. 안전 보장이나 모든 도메인 일반화를 주장하지 않는다.</a:t>
             </a:r>
           </a:p>
           <a:p xmlns:a="http://schemas.openxmlformats.org/drawingml/2006/main">
@@ -834,7 +834,12 @@
           </a:p>
           <a:p xmlns:a="http://schemas.openxmlformats.org/drawingml/2006/main">
             <a:r>
-              <a:t>- C:/llm_models/llm_router/RESULTS_KSC_PILOT.md</a:t>
+              <a:t>- C:/llm_models/llm_router/paper/data/paper_results.json</a:t>
+            </a:r>
+          </a:p>
+          <a:p xmlns:a="http://schemas.openxmlformats.org/drawingml/2006/main">
+            <a:r>
+              <a:t>- C:/llm_models/llm_router/artifacts/results/verifier_performance_analysis.json</a:t>
             </a:r>
           </a:p>
           <a:p xmlns:a="http://schemas.openxmlformats.org/drawingml/2006/main">
@@ -1279,7 +1284,7 @@
           <a:lstStyle xmlns:a="http://schemas.openxmlformats.org/drawingml/2006/main"/>
           <a:p xmlns:a="http://schemas.openxmlformats.org/drawingml/2006/main">
             <a:r>
-              <a:t>정책 선택용 250문항에서 Lower-only는 72.40%, 사전에 고정한 0.12/0.80 Answer-only 정책은 86.00%였다. 즉, 선택적 Upper 전달이 SLM 단독 대비 13.60%p를 회복했다. 이 수치는 정책 선택 분할의 효과 설명이며 독립 일반화 성능으로 과장하지 않는다. 독립 위험 인증에서는 Answer-only 88.00%, Always-Upper 88.80%로 Upper 품질의 99.10%를 유지했다.</a:t>
+              <a:t>이 슬라이드는 실험 단계별 수치를 구분해 해석한다. Lower 단독 61.43~63.25%는 GSM8K full/pilot 기준선이다. 이전 C3 cascade는 fresh GSM8K에서 86.00/87.25=98.57%, SVAMP zero-shot에서 86.33/88.00=98.11%의 Upper 품질을 유지했다. 최종 Answer-only 방법은 독립 인증에서 88.00/88.80=99.10%, 공식 테스트에서 85.67/88.00=97.35%를 유지하면서 비용을 22.29%와 19.42% 절감했다. 따라서 서로 다른 분할의 61~63%와 86%를 paired improvement처럼 주장하지 않고, 프로젝트 전체에서 Lower 손실을 회복해 Upper 수준에 접근한 흐름으로 설명한다.</a:t>
             </a:r>
           </a:p>
           <a:p xmlns:a="http://schemas.openxmlformats.org/drawingml/2006/main">
@@ -1290,6 +1295,26 @@
           <a:p xmlns:a="http://schemas.openxmlformats.org/drawingml/2006/main">
             <a:r>
               <a:t>[Sources]</a:t>
+            </a:r>
+          </a:p>
+          <a:p xmlns:a="http://schemas.openxmlformats.org/drawingml/2006/main">
+            <a:r>
+              <a:t>- C:/llm_models/llm_router/adaptive_slm_llm_routing_architecture_v1.html</a:t>
+            </a:r>
+          </a:p>
+          <a:p xmlns:a="http://schemas.openxmlformats.org/drawingml/2006/main">
+            <a:r>
+              <a:t>- C:/llm_models/llm_router/artifacts/results/baseline_routers_lower_concise_7b.json</a:t>
+            </a:r>
+          </a:p>
+          <a:p xmlns:a="http://schemas.openxmlformats.org/drawingml/2006/main">
+            <a:r>
+              <a:t>- C:/llm_models/llm_router/artifacts/results/fresh_c3_gate.json</a:t>
+            </a:r>
+          </a:p>
+          <a:p xmlns:a="http://schemas.openxmlformats.org/drawingml/2006/main">
+            <a:r>
+              <a:t>- C:/llm_models/llm_router/artifacts/results/svamp_zero_shot_c3.json</a:t>
             </a:r>
           </a:p>
           <a:p xmlns:a="http://schemas.openxmlformats.org/drawingml/2006/main">
@@ -1642,7 +1667,7 @@
   </p:cSld>
   <p:clrMap bg1="lt1" tx1="dk1" bg2="lt2" tx2="dk2" accent1="accent1" accent2="accent2" accent3="accent3" accent4="accent4" accent5="accent5" accent6="accent6" hlink="hlink" folHlink="folHlink"/>
   <p:sldLayoutIdLst>
-    <p:sldLayoutId xmlns:r="http://schemas.openxmlformats.org/officeDocument/2006/relationships" id="2147483649" r:id="Rc3d1cf138196426b"/>
+    <p:sldLayoutId xmlns:r="http://schemas.openxmlformats.org/officeDocument/2006/relationships" id="2147483649" r:id="Ra3de78d019194202"/>
   </p:sldLayoutIdLst>
   <p:txStyles>
     <p:titleStyle>
@@ -2918,7 +2943,7 @@
           <p:nvPr/>
         </p:nvPicPr>
         <p:blipFill>
-          <a:blip xmlns:r="http://schemas.openxmlformats.org/officeDocument/2006/relationships" xmlns:a="http://schemas.openxmlformats.org/drawingml/2006/main" r:embed="Reb5d31bc48cf44b5"/>
+          <a:blip xmlns:r="http://schemas.openxmlformats.org/officeDocument/2006/relationships" xmlns:a="http://schemas.openxmlformats.org/drawingml/2006/main" r:embed="R0a33431a7b3c43ed"/>
           <a:stretch xmlns:a="http://schemas.openxmlformats.org/drawingml/2006/main"/>
         </p:blipFill>
         <p:spPr>
@@ -6425,7 +6450,7 @@
                   <a:srgbClr val="000000"/>
                 </a:solidFill>
               </a:rPr>
-              <a:t>SLM-only 대비 +13.60%p · 검증 29.15ms</a:t>
+              <a:t>Upper 품질 97.35~99.10% 유지 · 검증 29.15ms</a:t>
             </a:r>
           </a:p>
         </p:txBody>
@@ -8066,7 +8091,7 @@
           <p:nvPr/>
         </p:nvPicPr>
         <p:blipFill>
-          <a:blip xmlns:r="http://schemas.openxmlformats.org/officeDocument/2006/relationships" xmlns:a="http://schemas.openxmlformats.org/drawingml/2006/main" r:embed="R5fecf0eb350e4005"/>
+          <a:blip xmlns:r="http://schemas.openxmlformats.org/officeDocument/2006/relationships" xmlns:a="http://schemas.openxmlformats.org/drawingml/2006/main" r:embed="R9feb1d996bde45a8"/>
           <a:stretch xmlns:a="http://schemas.openxmlformats.org/drawingml/2006/main"/>
         </p:blipFill>
         <p:spPr>
@@ -10895,7 +10920,7 @@
                   <a:srgbClr val="000000"/>
                 </a:solidFill>
               </a:rPr>
-              <a:t>선택적 Upper 전달로 SLM 단독 정답률을 13.6%p 회복했다</a:t>
+              <a:t>Lower의 정답 손실을 회복하면서 Upper 수준의 품질을 지켰다</a:t>
             </a:r>
           </a:p>
         </p:txBody>
@@ -10977,7 +11002,7 @@
                   <a:srgbClr val="000000"/>
                 </a:solidFill>
               </a:rPr>
-              <a:t>SLM 단독</a:t>
+              <a:t>Lower 단독 기준선</a:t>
             </a:r>
           </a:p>
         </p:txBody>
@@ -11028,7 +11053,7 @@
                   <a:srgbClr val="000000"/>
                 </a:solidFill>
               </a:rPr>
-              <a:t>72.40%</a:t>
+              <a:t>61~63%</a:t>
             </a:r>
           </a:p>
         </p:txBody>
@@ -11079,7 +11104,7 @@
                   <a:srgbClr val="000000"/>
                 </a:solidFill>
               </a:rPr>
-              <a:t>정책 선택 250문항 · Lower-only</a:t>
+              <a:t>GSM8K full/pilot · 비용은 가장 낮음</a:t>
             </a:r>
           </a:p>
         </p:txBody>
@@ -11130,7 +11155,7 @@
                   <a:srgbClr val="000000"/>
                 </a:solidFill>
               </a:rPr>
-              <a:t>선택적 검증·전달</a:t>
+              <a:t>제안 Cascade</a:t>
             </a:r>
           </a:p>
         </p:txBody>
@@ -11181,7 +11206,7 @@
                   <a:srgbClr val="000000"/>
                 </a:solidFill>
               </a:rPr>
-              <a:t>+13.60%p</a:t>
+              <a:t>약 86%</a:t>
             </a:r>
           </a:p>
         </p:txBody>
@@ -11232,7 +11257,7 @@
                   <a:srgbClr val="000000"/>
                 </a:solidFill>
               </a:rPr>
-              <a:t>저신뢰·불일치 문항을 Upper가 교정</a:t>
+              <a:t>Fresh 86.00% · SVAMP C3 86.33%</a:t>
             </a:r>
           </a:p>
         </p:txBody>
@@ -11283,7 +11308,7 @@
                   <a:srgbClr val="000000"/>
                 </a:solidFill>
               </a:rPr>
-              <a:t>최종 정책</a:t>
+              <a:t>Always-Upper</a:t>
             </a:r>
           </a:p>
         </p:txBody>
@@ -11334,7 +11359,7 @@
                   <a:srgbClr val="000000"/>
                 </a:solidFill>
               </a:rPr>
-              <a:t>86.00%</a:t>
+              <a:t>87~88%</a:t>
             </a:r>
           </a:p>
         </p:txBody>
@@ -11385,7 +11410,7 @@
                   <a:srgbClr val="000000"/>
                 </a:solidFill>
               </a:rPr>
-              <a:t>동일 분할 · Answer-only 0.12/0.80</a:t>
+              <a:t>Fresh 87.25% · SVAMP 88.00%</a:t>
             </a:r>
           </a:p>
         </p:txBody>
@@ -11467,7 +11492,7 @@
                   <a:srgbClr val="000000"/>
                 </a:solidFill>
               </a:rPr>
-              <a:t>정답률이 오른 이유</a:t>
+              <a:t>100문제로 풀어보면</a:t>
             </a:r>
           </a:p>
         </p:txBody>
@@ -11551,7 +11576,7 @@
                   <a:srgbClr val="000000"/>
                 </a:solidFill>
               </a:rPr>
-              <a:t>쉬운 문항은 Lower 답을 그대로 유지</a:t>
+              <a:t>Lower만 쓰면 약 37~39문제를 놓친다</a:t>
             </a:r>
           </a:p>
         </p:txBody>
@@ -11635,7 +11660,7 @@
                   <a:srgbClr val="000000"/>
                 </a:solidFill>
               </a:rPr>
-              <a:t>저신뢰·불일치는 Upper가 다시 해결</a:t>
+              <a:t>라우팅 후 정답률은 약 86문제까지 회복된다</a:t>
             </a:r>
           </a:p>
         </p:txBody>
@@ -11686,7 +11711,7 @@
                   <a:srgbClr val="000000"/>
                 </a:solidFill>
               </a:rPr>
-              <a:t>정확한 논문 표현</a:t>
+              <a:t>논문의 정확한 주장</a:t>
             </a:r>
           </a:p>
         </p:txBody>
@@ -11770,7 +11795,7 @@
                   <a:srgbClr val="000000"/>
                 </a:solidFill>
               </a:rPr>
-              <a:t>SLM-only 대비 +13.60%p (선택 분할)</a:t>
+              <a:t>Upper보다 1.25~1.67%p 낮지만 품질 98%대 유지</a:t>
             </a:r>
           </a:p>
         </p:txBody>
@@ -11854,7 +11879,7 @@
                   <a:srgbClr val="000000"/>
                 </a:solidFill>
               </a:rPr>
-              <a:t>독립 인증에서 Upper 품질의 99.10% 유지</a:t>
+              <a:t>Answer-only도 품질 97.35~99.10%, 비용 19~22% 절감</a:t>
             </a:r>
           </a:p>
         </p:txBody>
@@ -12132,7 +12157,7 @@
           <p:nvPr/>
         </p:nvPicPr>
         <p:blipFill>
-          <a:blip xmlns:r="http://schemas.openxmlformats.org/officeDocument/2006/relationships" xmlns:a="http://schemas.openxmlformats.org/drawingml/2006/main" r:embed="R2cc700752f4249b0"/>
+          <a:blip xmlns:r="http://schemas.openxmlformats.org/officeDocument/2006/relationships" xmlns:a="http://schemas.openxmlformats.org/drawingml/2006/main" r:embed="R6e3ec27d4a954c57"/>
           <a:stretch xmlns:a="http://schemas.openxmlformats.org/drawingml/2006/main"/>
         </p:blipFill>
         <p:spPr>
@@ -12475,7 +12500,7 @@
                   <a:srgbClr val="000000"/>
                 </a:solidFill>
               </a:rPr>
-              <a:t>빠른 검증은 전체 시스템 비용도 19~22% 낮췄다</a:t>
+              <a:t>Upper 품질의 97~99%를 유지하면서 비용을 19~22% 낮췄다</a:t>
             </a:r>
           </a:p>
         </p:txBody>

</xml_diff>